<commit_message>
Remove the closing slide from the deck
Co-Authored-By: Claude Sonnet 5.5 <noreply@anthropic.com>
Claude-Session: https://claude.ai/code/session_01G91AnPjqU4wM8Huv9evsac
</commit_message>
<xml_diff>
--- a/docs/Every_Last_Token.pptx
+++ b/docs/Every_Last_Token.pptx
@@ -26,10 +26,9 @@
     <p:sldId id="274" r:id="rId20"/>
     <p:sldId id="275" r:id="rId21"/>
     <p:sldId id="276" r:id="rId22"/>
-    <p:sldId id="277" r:id="rId23"/>
   </p:sldIdLst>
   <p:notesMasterIdLst>
-    <p:notesMasterId r:id="rId24"/>
+    <p:notesMasterId r:id="rId23"/>
   </p:notesMasterIdLst>
   <p:sldSz cx="9144000" cy="5143500"/>
   <p:notesSz cx="5143500" cy="9144000"/>
@@ -2311,94 +2310,6 @@
             <a:fld id="{F7021451-1387-4CA6-816F-3879F97B5CBC}" type="slidenum">
               <a:rPr lang="en-US"/>
               <a:t>21</a:t>
-            </a:fld>
-            <a:endParaRPr lang="en-US"/>
-          </a:p>
-        </p:txBody>
-      </p:sp>
-    </p:spTree>
-    <p:extLst>
-      <p:ext uri="{BB962C8B-B14F-4D97-AF65-F5344CB8AC3E}">
-        <p14:creationId xmlns:p14="http://schemas.microsoft.com/office/powerpoint/2010/main" val="1024086991"/>
-      </p:ext>
-    </p:extLst>
-  </p:cSld>
-  <p:clrMapOvr>
-    <a:masterClrMapping/>
-  </p:clrMapOvr>
-</p:notes>
-</file>
-
-<file path=ppt/notesSlides/notesSlide22.xml><?xml version="1.0" encoding="utf-8"?>
-<p:notes xmlns:a="http://schemas.openxmlformats.org/drawingml/2006/main" xmlns:r="http://schemas.openxmlformats.org/officeDocument/2006/relationships" xmlns:p="http://schemas.openxmlformats.org/presentationml/2006/main">
-  <p:cSld>
-    <p:spTree>
-      <p:nvGrpSpPr>
-        <p:cNvPr id="1" name=""/>
-        <p:cNvGrpSpPr/>
-        <p:nvPr/>
-      </p:nvGrpSpPr>
-      <p:grpSpPr>
-        <a:xfrm>
-          <a:off x="0" y="0"/>
-          <a:ext cx="0" cy="0"/>
-          <a:chOff x="0" y="0"/>
-          <a:chExt cx="0" cy="0"/>
-        </a:xfrm>
-      </p:grpSpPr>
-      <p:sp>
-        <p:nvSpPr>
-          <p:cNvPr id="2" name="Slide Image Placeholder 1"/>
-          <p:cNvSpPr>
-            <a:spLocks noGrp="1" noRot="1" noChangeAspect="1"/>
-          </p:cNvSpPr>
-          <p:nvPr>
-            <p:ph type="sldImg"/>
-          </p:nvPr>
-        </p:nvSpPr>
-        <p:spPr/>
-      </p:sp>
-      <p:sp>
-        <p:nvSpPr>
-          <p:cNvPr id="3" name="Notes Placeholder 2"/>
-          <p:cNvSpPr>
-            <a:spLocks noGrp="1"/>
-          </p:cNvSpPr>
-          <p:nvPr>
-            <p:ph type="body" idx="1"/>
-          </p:nvPr>
-        </p:nvSpPr>
-        <p:spPr/>
-        <p:txBody>
-          <a:bodyPr/>
-          <a:lstStyle/>
-          <a:p>
-            <a:r>
-              <a:rPr lang="en-US" dirty="0"/>
-              <a:t>Summary: Ramer helps when local decoding is the bottleneck, and we say clearly when it does not. Thank you.</a:t>
-            </a:r>
-            <a:endParaRPr lang="en-US" dirty="0"/>
-          </a:p>
-        </p:txBody>
-      </p:sp>
-      <p:sp>
-        <p:nvSpPr>
-          <p:cNvPr id="4" name="Slide Number Placeholder 3"/>
-          <p:cNvSpPr>
-            <a:spLocks noGrp="1"/>
-          </p:cNvSpPr>
-          <p:nvPr>
-            <p:ph type="sldNum" sz="quarter" idx="10"/>
-          </p:nvPr>
-        </p:nvSpPr>
-        <p:spPr/>
-        <p:txBody>
-          <a:bodyPr/>
-          <a:lstStyle/>
-          <a:p>
-            <a:fld id="{F7021451-1387-4CA6-816F-3879F97B5CBC}" type="slidenum">
-              <a:rPr lang="en-US"/>
-              <a:t>22</a:t>
             </a:fld>
             <a:endParaRPr lang="en-US"/>
           </a:p>
@@ -13284,155 +13195,6 @@
 </p:sld>
 </file>
 
-<file path=ppt/slides/slide22.xml><?xml version="1.0" encoding="utf-8"?>
-<p:sld xmlns:a="http://schemas.openxmlformats.org/drawingml/2006/main" xmlns:r="http://schemas.openxmlformats.org/officeDocument/2006/relationships" xmlns:p="http://schemas.openxmlformats.org/presentationml/2006/main">
-  <p:cSld name="Slide 22">
-    <p:bg>
-      <p:bgPr>
-        <a:solidFill>
-          <a:srgbClr val="000000"/>
-        </a:solidFill>
-      </p:bgPr>
-    </p:bg>
-    <p:spTree>
-      <p:nvGrpSpPr>
-        <p:cNvPr id="1" name=""/>
-        <p:cNvGrpSpPr/>
-        <p:nvPr/>
-      </p:nvGrpSpPr>
-      <p:grpSpPr>
-        <a:xfrm>
-          <a:off x="0" y="0"/>
-          <a:ext cx="0" cy="0"/>
-          <a:chOff x="0" y="0"/>
-          <a:chExt cx="0" cy="0"/>
-        </a:xfrm>
-      </p:grpSpPr>
-      <p:sp>
-        <p:nvSpPr>
-          <p:cNvPr id="3" name="Text 0"/>
-          <p:cNvSpPr txBox="1"/>
-          <p:nvPr/>
-        </p:nvSpPr>
-        <p:spPr>
-          <a:xfrm>
-            <a:off x="548640" y="1371600"/>
-            <a:ext cx="8046720" cy="822960"/>
-          </a:xfrm>
-          <a:prstGeom prst="rect">
-            <a:avLst/>
-          </a:prstGeom>
-          <a:noFill/>
-          <a:ln/>
-        </p:spPr>
-        <p:txBody>
-          <a:bodyPr wrap="square" lIns="0" tIns="0" rIns="0" bIns="0" rtlCol="0" anchor="b"/>
-          <a:lstStyle/>
-          <a:p>
-            <a:pPr indent="0" marL="0">
-              <a:buNone/>
-            </a:pPr>
-            <a:r>
-              <a:rPr lang="en-US" sz="4400" b="1" dirty="0">
-                <a:solidFill>
-                  <a:srgbClr val="FFFFFF"/>
-                </a:solidFill>
-                <a:latin typeface="Arial" pitchFamily="34" charset="0"/>
-                <a:ea typeface="Arial" pitchFamily="34" charset="-122"/>
-                <a:cs typeface="Arial" pitchFamily="34" charset="-120"/>
-              </a:rPr>
-              <a:t>Faster where it matters.</a:t>
-            </a:r>
-            <a:endParaRPr lang="en-US" sz="4400" dirty="0"/>
-          </a:p>
-        </p:txBody>
-      </p:sp>
-      <p:sp>
-        <p:nvSpPr>
-          <p:cNvPr id="4" name="Text 1"/>
-          <p:cNvSpPr txBox="1"/>
-          <p:nvPr/>
-        </p:nvSpPr>
-        <p:spPr>
-          <a:xfrm>
-            <a:off x="548640" y="2240280"/>
-            <a:ext cx="8046720" cy="731520"/>
-          </a:xfrm>
-          <a:prstGeom prst="rect">
-            <a:avLst/>
-          </a:prstGeom>
-          <a:noFill/>
-          <a:ln/>
-        </p:spPr>
-        <p:txBody>
-          <a:bodyPr wrap="square" lIns="0" tIns="0" rIns="0" bIns="0" rtlCol="0" anchor="t"/>
-          <a:lstStyle/>
-          <a:p>
-            <a:pPr indent="0" marL="0">
-              <a:buNone/>
-            </a:pPr>
-            <a:r>
-              <a:rPr lang="en-US" sz="4400" b="1" dirty="0">
-                <a:solidFill>
-                  <a:srgbClr val="8C8C8C"/>
-                </a:solidFill>
-                <a:latin typeface="Arial" pitchFamily="34" charset="0"/>
-                <a:ea typeface="Arial" pitchFamily="34" charset="-122"/>
-                <a:cs typeface="Arial" pitchFamily="34" charset="-120"/>
-              </a:rPr>
-              <a:t>Honest where it doesn't.</a:t>
-            </a:r>
-            <a:endParaRPr lang="en-US" sz="4400" dirty="0"/>
-          </a:p>
-        </p:txBody>
-      </p:sp>
-      <p:sp>
-        <p:nvSpPr>
-          <p:cNvPr id="5" name="Text 2"/>
-          <p:cNvSpPr txBox="1"/>
-          <p:nvPr/>
-        </p:nvSpPr>
-        <p:spPr>
-          <a:xfrm>
-            <a:off x="548640" y="4023360"/>
-            <a:ext cx="3657600" cy="457200"/>
-          </a:xfrm>
-          <a:prstGeom prst="rect">
-            <a:avLst/>
-          </a:prstGeom>
-          <a:noFill/>
-          <a:ln/>
-        </p:spPr>
-        <p:txBody>
-          <a:bodyPr wrap="square" lIns="0" tIns="0" rIns="0" bIns="0" rtlCol="0" anchor="ctr"/>
-          <a:lstStyle/>
-          <a:p>
-            <a:pPr indent="0" marL="0">
-              <a:buNone/>
-            </a:pPr>
-            <a:r>
-              <a:rPr lang="en-US" sz="1800" b="1" dirty="0">
-                <a:solidFill>
-                  <a:srgbClr val="FFFFFF"/>
-                </a:solidFill>
-                <a:latin typeface="Arial" pitchFamily="34" charset="0"/>
-                <a:ea typeface="Arial" pitchFamily="34" charset="-122"/>
-                <a:cs typeface="Arial" pitchFamily="34" charset="-120"/>
-              </a:rPr>
-              <a:t>Thank you</a:t>
-            </a:r>
-            <a:endParaRPr lang="en-US" sz="1800" dirty="0"/>
-          </a:p>
-        </p:txBody>
-      </p:sp>
-    </p:spTree>
-  </p:cSld>
-  <p:clrMapOvr>
-    <a:masterClrMapping/>
-  </p:clrMapOvr>
-</p:sld>
-</file>
-
 <file path=ppt/slides/slide3.xml><?xml version="1.0" encoding="utf-8"?>
 <p:sld xmlns:a="http://schemas.openxmlformats.org/drawingml/2006/main" xmlns:r="http://schemas.openxmlformats.org/officeDocument/2006/relationships" xmlns:p="http://schemas.openxmlformats.org/presentationml/2006/main">
   <p:cSld name="Slide 3">

</xml_diff>

<commit_message>
Add the Implement step to the design thinking deck
Co-Authored-By: Claude Sonnet 5.5 <noreply@anthropic.com>
Claude-Session: https://claude.ai/code/session_01G91AnPjqU4wM8Huv9evsac
</commit_message>
<xml_diff>
--- a/docs/Every_Last_Token.pptx
+++ b/docs/Every_Last_Token.pptx
@@ -26,9 +26,12 @@
     <p:sldId id="274" r:id="rId20"/>
     <p:sldId id="275" r:id="rId21"/>
     <p:sldId id="276" r:id="rId22"/>
+    <p:sldId id="277" r:id="rId23"/>
+    <p:sldId id="278" r:id="rId24"/>
+    <p:sldId id="279" r:id="rId25"/>
   </p:sldIdLst>
   <p:notesMasterIdLst>
-    <p:notesMasterId r:id="rId23"/>
+    <p:notesMasterId r:id="rId26"/>
   </p:notesMasterIdLst>
   <p:sldSz cx="9144000" cy="5143500"/>
   <p:notesSz cx="5143500" cy="9144000"/>
@@ -1142,7 +1145,7 @@
           <a:p>
             <a:r>
               <a:rPr lang="en-US" dirty="0"/>
-              <a:t>Ramer is a small tool that sits between your local AI agent and Ollama and makes your GPU work harder. This deck tells the story of how it was built using the five steps of design thinking.</a:t>
+              <a:t>Ramer is a small tool that sits between your local AI agent and Ollama and makes your GPU work harder. This deck tells the story of how it was built using the six steps of design thinking.</a:t>
             </a:r>
             <a:endParaRPr lang="en-US" dirty="0"/>
           </a:p>
@@ -2286,7 +2289,7 @@
           <a:p>
             <a:r>
               <a:rPr lang="en-US" dirty="0"/>
-              <a:t>Design thinking never really ends. The technical validation is closed; the next input the project needs is real customer interviews, which restarts the cycle at Empathize.</a:t>
+              <a:t>Implement is the step many versions of design thinking add after Test. It is about delivery: how the solution reaches users and gets adopted.</a:t>
             </a:r>
             <a:endParaRPr lang="en-US" dirty="0"/>
           </a:p>
@@ -2310,6 +2313,270 @@
             <a:fld id="{F7021451-1387-4CA6-816F-3879F97B5CBC}" type="slidenum">
               <a:rPr lang="en-US"/>
               <a:t>21</a:t>
+            </a:fld>
+            <a:endParaRPr lang="en-US"/>
+          </a:p>
+        </p:txBody>
+      </p:sp>
+    </p:spTree>
+    <p:extLst>
+      <p:ext uri="{BB962C8B-B14F-4D97-AF65-F5344CB8AC3E}">
+        <p14:creationId xmlns:p14="http://schemas.microsoft.com/office/powerpoint/2010/main" val="1024086991"/>
+      </p:ext>
+    </p:extLst>
+  </p:cSld>
+  <p:clrMapOvr>
+    <a:masterClrMapping/>
+  </p:clrMapOvr>
+</p:notes>
+</file>
+
+<file path=ppt/notesSlides/notesSlide22.xml><?xml version="1.0" encoding="utf-8"?>
+<p:notes xmlns:a="http://schemas.openxmlformats.org/drawingml/2006/main" xmlns:r="http://schemas.openxmlformats.org/officeDocument/2006/relationships" xmlns:p="http://schemas.openxmlformats.org/presentationml/2006/main">
+  <p:cSld>
+    <p:spTree>
+      <p:nvGrpSpPr>
+        <p:cNvPr id="1" name=""/>
+        <p:cNvGrpSpPr/>
+        <p:nvPr/>
+      </p:nvGrpSpPr>
+      <p:grpSpPr>
+        <a:xfrm>
+          <a:off x="0" y="0"/>
+          <a:ext cx="0" cy="0"/>
+          <a:chOff x="0" y="0"/>
+          <a:chExt cx="0" cy="0"/>
+        </a:xfrm>
+      </p:grpSpPr>
+      <p:sp>
+        <p:nvSpPr>
+          <p:cNvPr id="2" name="Slide Image Placeholder 1"/>
+          <p:cNvSpPr>
+            <a:spLocks noGrp="1" noRot="1" noChangeAspect="1"/>
+          </p:cNvSpPr>
+          <p:nvPr>
+            <p:ph type="sldImg"/>
+          </p:nvPr>
+        </p:nvSpPr>
+        <p:spPr/>
+      </p:sp>
+      <p:sp>
+        <p:nvSpPr>
+          <p:cNvPr id="3" name="Notes Placeholder 2"/>
+          <p:cNvSpPr>
+            <a:spLocks noGrp="1"/>
+          </p:cNvSpPr>
+          <p:nvPr>
+            <p:ph type="body" idx="1"/>
+          </p:nvPr>
+        </p:nvSpPr>
+        <p:spPr/>
+        <p:txBody>
+          <a:bodyPr/>
+          <a:lstStyle/>
+          <a:p>
+            <a:r>
+              <a:rPr lang="en-US" dirty="0"/>
+              <a:t>Requirements: Python 3.10 or newer, a local Ollama install and a discrete NVIDIA GPU. It was built and tested on Windows; Linux is untested. Confirmed working end to end with aider and the pi CLI, including real tool-calling tasks.</a:t>
+            </a:r>
+            <a:endParaRPr lang="en-US" dirty="0"/>
+          </a:p>
+        </p:txBody>
+      </p:sp>
+      <p:sp>
+        <p:nvSpPr>
+          <p:cNvPr id="4" name="Slide Number Placeholder 3"/>
+          <p:cNvSpPr>
+            <a:spLocks noGrp="1"/>
+          </p:cNvSpPr>
+          <p:nvPr>
+            <p:ph type="sldNum" sz="quarter" idx="10"/>
+          </p:nvPr>
+        </p:nvSpPr>
+        <p:spPr/>
+        <p:txBody>
+          <a:bodyPr/>
+          <a:lstStyle/>
+          <a:p>
+            <a:fld id="{F7021451-1387-4CA6-816F-3879F97B5CBC}" type="slidenum">
+              <a:rPr lang="en-US"/>
+              <a:t>22</a:t>
+            </a:fld>
+            <a:endParaRPr lang="en-US"/>
+          </a:p>
+        </p:txBody>
+      </p:sp>
+    </p:spTree>
+    <p:extLst>
+      <p:ext uri="{BB962C8B-B14F-4D97-AF65-F5344CB8AC3E}">
+        <p14:creationId xmlns:p14="http://schemas.microsoft.com/office/powerpoint/2010/main" val="1024086991"/>
+      </p:ext>
+    </p:extLst>
+  </p:cSld>
+  <p:clrMapOvr>
+    <a:masterClrMapping/>
+  </p:clrMapOvr>
+</p:notes>
+</file>
+
+<file path=ppt/notesSlides/notesSlide23.xml><?xml version="1.0" encoding="utf-8"?>
+<p:notes xmlns:a="http://schemas.openxmlformats.org/drawingml/2006/main" xmlns:r="http://schemas.openxmlformats.org/officeDocument/2006/relationships" xmlns:p="http://schemas.openxmlformats.org/presentationml/2006/main">
+  <p:cSld>
+    <p:spTree>
+      <p:nvGrpSpPr>
+        <p:cNvPr id="1" name=""/>
+        <p:cNvGrpSpPr/>
+        <p:nvPr/>
+      </p:nvGrpSpPr>
+      <p:grpSpPr>
+        <a:xfrm>
+          <a:off x="0" y="0"/>
+          <a:ext cx="0" cy="0"/>
+          <a:chOff x="0" y="0"/>
+          <a:chExt cx="0" cy="0"/>
+        </a:xfrm>
+      </p:grpSpPr>
+      <p:sp>
+        <p:nvSpPr>
+          <p:cNvPr id="2" name="Slide Image Placeholder 1"/>
+          <p:cNvSpPr>
+            <a:spLocks noGrp="1" noRot="1" noChangeAspect="1"/>
+          </p:cNvSpPr>
+          <p:nvPr>
+            <p:ph type="sldImg"/>
+          </p:nvPr>
+        </p:nvSpPr>
+        <p:spPr/>
+      </p:sp>
+      <p:sp>
+        <p:nvSpPr>
+          <p:cNvPr id="3" name="Notes Placeholder 2"/>
+          <p:cNvSpPr>
+            <a:spLocks noGrp="1"/>
+          </p:cNvSpPr>
+          <p:nvPr>
+            <p:ph type="body" idx="1"/>
+          </p:nvPr>
+        </p:nvSpPr>
+        <p:spPr/>
+        <p:txBody>
+          <a:bodyPr/>
+          <a:lstStyle/>
+          <a:p>
+            <a:r>
+              <a:rPr lang="en-US" dirty="0"/>
+              <a:t>Honest status: the technical build is done and internally validated. Customer discovery has not happened yet. The rollout plan is to put Ramer in front of real users through interviews and ask for unvarnished feedback.</a:t>
+            </a:r>
+            <a:endParaRPr lang="en-US" dirty="0"/>
+          </a:p>
+        </p:txBody>
+      </p:sp>
+      <p:sp>
+        <p:nvSpPr>
+          <p:cNvPr id="4" name="Slide Number Placeholder 3"/>
+          <p:cNvSpPr>
+            <a:spLocks noGrp="1"/>
+          </p:cNvSpPr>
+          <p:nvPr>
+            <p:ph type="sldNum" sz="quarter" idx="10"/>
+          </p:nvPr>
+        </p:nvSpPr>
+        <p:spPr/>
+        <p:txBody>
+          <a:bodyPr/>
+          <a:lstStyle/>
+          <a:p>
+            <a:fld id="{F7021451-1387-4CA6-816F-3879F97B5CBC}" type="slidenum">
+              <a:rPr lang="en-US"/>
+              <a:t>23</a:t>
+            </a:fld>
+            <a:endParaRPr lang="en-US"/>
+          </a:p>
+        </p:txBody>
+      </p:sp>
+    </p:spTree>
+    <p:extLst>
+      <p:ext uri="{BB962C8B-B14F-4D97-AF65-F5344CB8AC3E}">
+        <p14:creationId xmlns:p14="http://schemas.microsoft.com/office/powerpoint/2010/main" val="1024086991"/>
+      </p:ext>
+    </p:extLst>
+  </p:cSld>
+  <p:clrMapOvr>
+    <a:masterClrMapping/>
+  </p:clrMapOvr>
+</p:notes>
+</file>
+
+<file path=ppt/notesSlides/notesSlide24.xml><?xml version="1.0" encoding="utf-8"?>
+<p:notes xmlns:a="http://schemas.openxmlformats.org/drawingml/2006/main" xmlns:r="http://schemas.openxmlformats.org/officeDocument/2006/relationships" xmlns:p="http://schemas.openxmlformats.org/presentationml/2006/main">
+  <p:cSld>
+    <p:spTree>
+      <p:nvGrpSpPr>
+        <p:cNvPr id="1" name=""/>
+        <p:cNvGrpSpPr/>
+        <p:nvPr/>
+      </p:nvGrpSpPr>
+      <p:grpSpPr>
+        <a:xfrm>
+          <a:off x="0" y="0"/>
+          <a:ext cx="0" cy="0"/>
+          <a:chOff x="0" y="0"/>
+          <a:chExt cx="0" cy="0"/>
+        </a:xfrm>
+      </p:grpSpPr>
+      <p:sp>
+        <p:nvSpPr>
+          <p:cNvPr id="2" name="Slide Image Placeholder 1"/>
+          <p:cNvSpPr>
+            <a:spLocks noGrp="1" noRot="1" noChangeAspect="1"/>
+          </p:cNvSpPr>
+          <p:nvPr>
+            <p:ph type="sldImg"/>
+          </p:nvPr>
+        </p:nvSpPr>
+        <p:spPr/>
+      </p:sp>
+      <p:sp>
+        <p:nvSpPr>
+          <p:cNvPr id="3" name="Notes Placeholder 2"/>
+          <p:cNvSpPr>
+            <a:spLocks noGrp="1"/>
+          </p:cNvSpPr>
+          <p:nvPr>
+            <p:ph type="body" idx="1"/>
+          </p:nvPr>
+        </p:nvSpPr>
+        <p:spPr/>
+        <p:txBody>
+          <a:bodyPr/>
+          <a:lstStyle/>
+          <a:p>
+            <a:r>
+              <a:rPr lang="en-US" dirty="0"/>
+              <a:t>Design thinking never really ends. The technical validation is closed; the next input the project needs is real customer interviews, which restarts the cycle at Empathize.</a:t>
+            </a:r>
+            <a:endParaRPr lang="en-US" dirty="0"/>
+          </a:p>
+        </p:txBody>
+      </p:sp>
+      <p:sp>
+        <p:nvSpPr>
+          <p:cNvPr id="4" name="Slide Number Placeholder 3"/>
+          <p:cNvSpPr>
+            <a:spLocks noGrp="1"/>
+          </p:cNvSpPr>
+          <p:nvPr>
+            <p:ph type="sldNum" sz="quarter" idx="10"/>
+          </p:nvPr>
+        </p:nvSpPr>
+        <p:spPr/>
+        <p:txBody>
+          <a:bodyPr/>
+          <a:lstStyle/>
+          <a:p>
+            <a:fld id="{F7021451-1387-4CA6-816F-3879F97B5CBC}" type="slidenum">
+              <a:rPr lang="en-US"/>
+              <a:t>24</a:t>
             </a:fld>
             <a:endParaRPr lang="en-US"/>
           </a:p>
@@ -3417,7 +3684,7 @@
               <a:buNone/>
             </a:pPr>
             <a:r>
-              <a:rPr lang="en-US" sz="1300" b="1" spc="200" kern="0" dirty="0">
+              <a:rPr lang="en-US" sz="1200" b="1" spc="100" kern="0" dirty="0">
                 <a:solidFill>
                   <a:srgbClr val="8C8C8C"/>
                 </a:solidFill>
@@ -3425,9 +3692,9 @@
                 <a:ea typeface="Arial" pitchFamily="34" charset="-122"/>
                 <a:cs typeface="Arial" pitchFamily="34" charset="-120"/>
               </a:rPr>
-              <a:t>EMPATHIZE   ·   DEFINE   ·   IDEATE   ·   PROTOTYPE   ·   TEST</a:t>
-            </a:r>
-            <a:endParaRPr lang="en-US" sz="1300" dirty="0"/>
+              <a:t>EMPATHIZE  ·  DEFINE  ·  IDEATE  ·  PROTOTYPE  ·  TEST  ·  IMPLEMENT</a:t>
+            </a:r>
+            <a:endParaRPr lang="en-US" sz="1200" dirty="0"/>
           </a:p>
         </p:txBody>
       </p:sp>
@@ -3588,8 +3855,8 @@
         </p:nvSpPr>
         <p:spPr>
           <a:xfrm>
-            <a:off x="548640" y="3429000"/>
-            <a:ext cx="457200" cy="256032"/>
+            <a:off x="548640" y="3108960"/>
+            <a:ext cx="457200" cy="246888"/>
           </a:xfrm>
           <a:prstGeom prst="rect">
             <a:avLst/>
@@ -3627,8 +3894,8 @@
         </p:nvSpPr>
         <p:spPr>
           <a:xfrm>
-            <a:off x="1005840" y="3429000"/>
-            <a:ext cx="2743200" cy="256032"/>
+            <a:off x="1005840" y="3108960"/>
+            <a:ext cx="2743200" cy="246888"/>
           </a:xfrm>
           <a:prstGeom prst="rect">
             <a:avLst/>
@@ -3666,8 +3933,8 @@
         </p:nvSpPr>
         <p:spPr>
           <a:xfrm>
-            <a:off x="548640" y="3685032"/>
-            <a:ext cx="457200" cy="256032"/>
+            <a:off x="548640" y="3355848"/>
+            <a:ext cx="457200" cy="246888"/>
           </a:xfrm>
           <a:prstGeom prst="rect">
             <a:avLst/>
@@ -3705,8 +3972,8 @@
         </p:nvSpPr>
         <p:spPr>
           <a:xfrm>
-            <a:off x="1005840" y="3685032"/>
-            <a:ext cx="2743200" cy="256032"/>
+            <a:off x="1005840" y="3355848"/>
+            <a:ext cx="2743200" cy="246888"/>
           </a:xfrm>
           <a:prstGeom prst="rect">
             <a:avLst/>
@@ -3744,8 +4011,8 @@
         </p:nvSpPr>
         <p:spPr>
           <a:xfrm>
-            <a:off x="548640" y="3941064"/>
-            <a:ext cx="457200" cy="256032"/>
+            <a:off x="548640" y="3602736"/>
+            <a:ext cx="457200" cy="246888"/>
           </a:xfrm>
           <a:prstGeom prst="rect">
             <a:avLst/>
@@ -3783,8 +4050,8 @@
         </p:nvSpPr>
         <p:spPr>
           <a:xfrm>
-            <a:off x="1005840" y="3941064"/>
-            <a:ext cx="2743200" cy="256032"/>
+            <a:off x="1005840" y="3602736"/>
+            <a:ext cx="2743200" cy="246888"/>
           </a:xfrm>
           <a:prstGeom prst="rect">
             <a:avLst/>
@@ -3822,8 +4089,8 @@
         </p:nvSpPr>
         <p:spPr>
           <a:xfrm>
-            <a:off x="548640" y="4197096"/>
-            <a:ext cx="457200" cy="256032"/>
+            <a:off x="548640" y="3849624"/>
+            <a:ext cx="457200" cy="246888"/>
           </a:xfrm>
           <a:prstGeom prst="rect">
             <a:avLst/>
@@ -3861,8 +4128,8 @@
         </p:nvSpPr>
         <p:spPr>
           <a:xfrm>
-            <a:off x="1005840" y="4197096"/>
-            <a:ext cx="2743200" cy="256032"/>
+            <a:off x="1005840" y="3849624"/>
+            <a:ext cx="2743200" cy="246888"/>
           </a:xfrm>
           <a:prstGeom prst="rect">
             <a:avLst/>
@@ -3900,8 +4167,8 @@
         </p:nvSpPr>
         <p:spPr>
           <a:xfrm>
-            <a:off x="548640" y="4453128"/>
-            <a:ext cx="457200" cy="256032"/>
+            <a:off x="548640" y="4096512"/>
+            <a:ext cx="457200" cy="246888"/>
           </a:xfrm>
           <a:prstGeom prst="rect">
             <a:avLst/>
@@ -3939,8 +4206,8 @@
         </p:nvSpPr>
         <p:spPr>
           <a:xfrm>
-            <a:off x="1005840" y="4453128"/>
-            <a:ext cx="2743200" cy="256032"/>
+            <a:off x="1005840" y="4096512"/>
+            <a:ext cx="2743200" cy="246888"/>
           </a:xfrm>
           <a:prstGeom prst="rect">
             <a:avLst/>
@@ -3972,7 +4239,85 @@
       </p:sp>
       <p:sp>
         <p:nvSpPr>
-          <p:cNvPr id="16" name="Shape 13"/>
+          <p:cNvPr id="16" name="Text 13"/>
+          <p:cNvSpPr txBox="1"/>
+          <p:nvPr/>
+        </p:nvSpPr>
+        <p:spPr>
+          <a:xfrm>
+            <a:off x="548640" y="4343400"/>
+            <a:ext cx="457200" cy="246888"/>
+          </a:xfrm>
+          <a:prstGeom prst="rect">
+            <a:avLst/>
+          </a:prstGeom>
+          <a:noFill/>
+          <a:ln/>
+        </p:spPr>
+        <p:txBody>
+          <a:bodyPr wrap="square" lIns="0" tIns="0" rIns="0" bIns="0" rtlCol="0" anchor="ctr"/>
+          <a:lstStyle/>
+          <a:p>
+            <a:pPr indent="0" marL="0">
+              <a:buNone/>
+            </a:pPr>
+            <a:r>
+              <a:rPr lang="en-US" sz="1200" b="1" dirty="0">
+                <a:solidFill>
+                  <a:srgbClr val="595959"/>
+                </a:solidFill>
+                <a:latin typeface="Arial" pitchFamily="34" charset="0"/>
+                <a:ea typeface="Arial" pitchFamily="34" charset="-122"/>
+                <a:cs typeface="Arial" pitchFamily="34" charset="-120"/>
+              </a:rPr>
+              <a:t>06</a:t>
+            </a:r>
+            <a:endParaRPr lang="en-US" sz="1200" dirty="0"/>
+          </a:p>
+        </p:txBody>
+      </p:sp>
+      <p:sp>
+        <p:nvSpPr>
+          <p:cNvPr id="17" name="Text 14"/>
+          <p:cNvSpPr txBox="1"/>
+          <p:nvPr/>
+        </p:nvSpPr>
+        <p:spPr>
+          <a:xfrm>
+            <a:off x="1005840" y="4343400"/>
+            <a:ext cx="2743200" cy="246888"/>
+          </a:xfrm>
+          <a:prstGeom prst="rect">
+            <a:avLst/>
+          </a:prstGeom>
+          <a:noFill/>
+          <a:ln/>
+        </p:spPr>
+        <p:txBody>
+          <a:bodyPr wrap="square" lIns="0" tIns="0" rIns="0" bIns="0" rtlCol="0" anchor="ctr"/>
+          <a:lstStyle/>
+          <a:p>
+            <a:pPr indent="0" marL="0">
+              <a:buNone/>
+            </a:pPr>
+            <a:r>
+              <a:rPr lang="en-US" sz="1200" dirty="0">
+                <a:solidFill>
+                  <a:srgbClr val="595959"/>
+                </a:solidFill>
+                <a:latin typeface="Arial" pitchFamily="34" charset="0"/>
+                <a:ea typeface="Arial" pitchFamily="34" charset="-122"/>
+                <a:cs typeface="Arial" pitchFamily="34" charset="-120"/>
+              </a:rPr>
+              <a:t>Implement</a:t>
+            </a:r>
+            <a:endParaRPr lang="en-US" sz="1200" dirty="0"/>
+          </a:p>
+        </p:txBody>
+      </p:sp>
+      <p:sp>
+        <p:nvSpPr>
+          <p:cNvPr id="18" name="Shape 15"/>
           <p:cNvSpPr/>
           <p:nvPr/>
         </p:nvSpPr>
@@ -3997,7 +4342,7 @@
       </p:sp>
       <p:sp>
         <p:nvSpPr>
-          <p:cNvPr id="17" name="Text 14"/>
+          <p:cNvPr id="19" name="Text 16"/>
           <p:cNvSpPr txBox="1"/>
           <p:nvPr/>
         </p:nvSpPr>
@@ -4036,7 +4381,7 @@
       </p:sp>
       <p:sp>
         <p:nvSpPr>
-          <p:cNvPr id="18" name="Text 15"/>
+          <p:cNvPr id="20" name="Text 17"/>
           <p:cNvSpPr txBox="1"/>
           <p:nvPr/>
         </p:nvSpPr>
@@ -4075,7 +4420,7 @@
       </p:sp>
       <p:sp>
         <p:nvSpPr>
-          <p:cNvPr id="19" name="Text 16"/>
+          <p:cNvPr id="21" name="Text 18"/>
           <p:cNvSpPr txBox="1"/>
           <p:nvPr/>
         </p:nvSpPr>
@@ -4114,7 +4459,7 @@
       </p:sp>
       <p:sp>
         <p:nvSpPr>
-          <p:cNvPr id="20" name="Text 17"/>
+          <p:cNvPr id="22" name="Text 19"/>
           <p:cNvSpPr txBox="1"/>
           <p:nvPr/>
         </p:nvSpPr>
@@ -4153,7 +4498,7 @@
       </p:sp>
       <p:sp>
         <p:nvSpPr>
-          <p:cNvPr id="21" name="Text 18"/>
+          <p:cNvPr id="23" name="Text 20"/>
           <p:cNvSpPr txBox="1"/>
           <p:nvPr/>
         </p:nvSpPr>
@@ -4192,7 +4537,7 @@
       </p:sp>
       <p:sp>
         <p:nvSpPr>
-          <p:cNvPr id="22" name="Text 19"/>
+          <p:cNvPr id="24" name="Text 21"/>
           <p:cNvSpPr txBox="1"/>
           <p:nvPr/>
         </p:nvSpPr>
@@ -6104,8 +6449,8 @@
         </p:nvSpPr>
         <p:spPr>
           <a:xfrm>
-            <a:off x="548640" y="3429000"/>
-            <a:ext cx="457200" cy="256032"/>
+            <a:off x="548640" y="3108960"/>
+            <a:ext cx="457200" cy="246888"/>
           </a:xfrm>
           <a:prstGeom prst="rect">
             <a:avLst/>
@@ -6143,8 +6488,8 @@
         </p:nvSpPr>
         <p:spPr>
           <a:xfrm>
-            <a:off x="1005840" y="3429000"/>
-            <a:ext cx="2743200" cy="256032"/>
+            <a:off x="1005840" y="3108960"/>
+            <a:ext cx="2743200" cy="246888"/>
           </a:xfrm>
           <a:prstGeom prst="rect">
             <a:avLst/>
@@ -6182,8 +6527,8 @@
         </p:nvSpPr>
         <p:spPr>
           <a:xfrm>
-            <a:off x="548640" y="3685032"/>
-            <a:ext cx="457200" cy="256032"/>
+            <a:off x="548640" y="3355848"/>
+            <a:ext cx="457200" cy="246888"/>
           </a:xfrm>
           <a:prstGeom prst="rect">
             <a:avLst/>
@@ -6221,8 +6566,8 @@
         </p:nvSpPr>
         <p:spPr>
           <a:xfrm>
-            <a:off x="1005840" y="3685032"/>
-            <a:ext cx="2743200" cy="256032"/>
+            <a:off x="1005840" y="3355848"/>
+            <a:ext cx="2743200" cy="246888"/>
           </a:xfrm>
           <a:prstGeom prst="rect">
             <a:avLst/>
@@ -6260,8 +6605,8 @@
         </p:nvSpPr>
         <p:spPr>
           <a:xfrm>
-            <a:off x="548640" y="3941064"/>
-            <a:ext cx="457200" cy="256032"/>
+            <a:off x="548640" y="3602736"/>
+            <a:ext cx="457200" cy="246888"/>
           </a:xfrm>
           <a:prstGeom prst="rect">
             <a:avLst/>
@@ -6299,8 +6644,8 @@
         </p:nvSpPr>
         <p:spPr>
           <a:xfrm>
-            <a:off x="1005840" y="3941064"/>
-            <a:ext cx="2743200" cy="256032"/>
+            <a:off x="1005840" y="3602736"/>
+            <a:ext cx="2743200" cy="246888"/>
           </a:xfrm>
           <a:prstGeom prst="rect">
             <a:avLst/>
@@ -6338,8 +6683,8 @@
         </p:nvSpPr>
         <p:spPr>
           <a:xfrm>
-            <a:off x="548640" y="4197096"/>
-            <a:ext cx="457200" cy="256032"/>
+            <a:off x="548640" y="3849624"/>
+            <a:ext cx="457200" cy="246888"/>
           </a:xfrm>
           <a:prstGeom prst="rect">
             <a:avLst/>
@@ -6377,8 +6722,8 @@
         </p:nvSpPr>
         <p:spPr>
           <a:xfrm>
-            <a:off x="1005840" y="4197096"/>
-            <a:ext cx="2743200" cy="256032"/>
+            <a:off x="1005840" y="3849624"/>
+            <a:ext cx="2743200" cy="246888"/>
           </a:xfrm>
           <a:prstGeom prst="rect">
             <a:avLst/>
@@ -6416,8 +6761,8 @@
         </p:nvSpPr>
         <p:spPr>
           <a:xfrm>
-            <a:off x="548640" y="4453128"/>
-            <a:ext cx="457200" cy="256032"/>
+            <a:off x="548640" y="4096512"/>
+            <a:ext cx="457200" cy="246888"/>
           </a:xfrm>
           <a:prstGeom prst="rect">
             <a:avLst/>
@@ -6455,8 +6800,8 @@
         </p:nvSpPr>
         <p:spPr>
           <a:xfrm>
-            <a:off x="1005840" y="4453128"/>
-            <a:ext cx="2743200" cy="256032"/>
+            <a:off x="1005840" y="4096512"/>
+            <a:ext cx="2743200" cy="246888"/>
           </a:xfrm>
           <a:prstGeom prst="rect">
             <a:avLst/>
@@ -6488,7 +6833,85 @@
       </p:sp>
       <p:sp>
         <p:nvSpPr>
-          <p:cNvPr id="16" name="Shape 13"/>
+          <p:cNvPr id="16" name="Text 13"/>
+          <p:cNvSpPr txBox="1"/>
+          <p:nvPr/>
+        </p:nvSpPr>
+        <p:spPr>
+          <a:xfrm>
+            <a:off x="548640" y="4343400"/>
+            <a:ext cx="457200" cy="246888"/>
+          </a:xfrm>
+          <a:prstGeom prst="rect">
+            <a:avLst/>
+          </a:prstGeom>
+          <a:noFill/>
+          <a:ln/>
+        </p:spPr>
+        <p:txBody>
+          <a:bodyPr wrap="square" lIns="0" tIns="0" rIns="0" bIns="0" rtlCol="0" anchor="ctr"/>
+          <a:lstStyle/>
+          <a:p>
+            <a:pPr indent="0" marL="0">
+              <a:buNone/>
+            </a:pPr>
+            <a:r>
+              <a:rPr lang="en-US" sz="1200" b="1" dirty="0">
+                <a:solidFill>
+                  <a:srgbClr val="595959"/>
+                </a:solidFill>
+                <a:latin typeface="Arial" pitchFamily="34" charset="0"/>
+                <a:ea typeface="Arial" pitchFamily="34" charset="-122"/>
+                <a:cs typeface="Arial" pitchFamily="34" charset="-120"/>
+              </a:rPr>
+              <a:t>06</a:t>
+            </a:r>
+            <a:endParaRPr lang="en-US" sz="1200" dirty="0"/>
+          </a:p>
+        </p:txBody>
+      </p:sp>
+      <p:sp>
+        <p:nvSpPr>
+          <p:cNvPr id="17" name="Text 14"/>
+          <p:cNvSpPr txBox="1"/>
+          <p:nvPr/>
+        </p:nvSpPr>
+        <p:spPr>
+          <a:xfrm>
+            <a:off x="1005840" y="4343400"/>
+            <a:ext cx="2743200" cy="246888"/>
+          </a:xfrm>
+          <a:prstGeom prst="rect">
+            <a:avLst/>
+          </a:prstGeom>
+          <a:noFill/>
+          <a:ln/>
+        </p:spPr>
+        <p:txBody>
+          <a:bodyPr wrap="square" lIns="0" tIns="0" rIns="0" bIns="0" rtlCol="0" anchor="ctr"/>
+          <a:lstStyle/>
+          <a:p>
+            <a:pPr indent="0" marL="0">
+              <a:buNone/>
+            </a:pPr>
+            <a:r>
+              <a:rPr lang="en-US" sz="1200" dirty="0">
+                <a:solidFill>
+                  <a:srgbClr val="595959"/>
+                </a:solidFill>
+                <a:latin typeface="Arial" pitchFamily="34" charset="0"/>
+                <a:ea typeface="Arial" pitchFamily="34" charset="-122"/>
+                <a:cs typeface="Arial" pitchFamily="34" charset="-120"/>
+              </a:rPr>
+              <a:t>Implement</a:t>
+            </a:r>
+            <a:endParaRPr lang="en-US" sz="1200" dirty="0"/>
+          </a:p>
+        </p:txBody>
+      </p:sp>
+      <p:sp>
+        <p:nvSpPr>
+          <p:cNvPr id="18" name="Shape 15"/>
           <p:cNvSpPr/>
           <p:nvPr/>
         </p:nvSpPr>
@@ -6513,7 +6936,7 @@
       </p:sp>
       <p:sp>
         <p:nvSpPr>
-          <p:cNvPr id="17" name="Text 14"/>
+          <p:cNvPr id="19" name="Text 16"/>
           <p:cNvSpPr txBox="1"/>
           <p:nvPr/>
         </p:nvSpPr>
@@ -6552,7 +6975,7 @@
       </p:sp>
       <p:sp>
         <p:nvSpPr>
-          <p:cNvPr id="18" name="Text 15"/>
+          <p:cNvPr id="20" name="Text 17"/>
           <p:cNvSpPr txBox="1"/>
           <p:nvPr/>
         </p:nvSpPr>
@@ -6591,7 +7014,7 @@
       </p:sp>
       <p:sp>
         <p:nvSpPr>
-          <p:cNvPr id="19" name="Text 16"/>
+          <p:cNvPr id="21" name="Text 18"/>
           <p:cNvSpPr txBox="1"/>
           <p:nvPr/>
         </p:nvSpPr>
@@ -6630,7 +7053,7 @@
       </p:sp>
       <p:sp>
         <p:nvSpPr>
-          <p:cNvPr id="20" name="Text 17"/>
+          <p:cNvPr id="22" name="Text 19"/>
           <p:cNvSpPr txBox="1"/>
           <p:nvPr/>
         </p:nvSpPr>
@@ -6669,7 +7092,7 @@
       </p:sp>
       <p:sp>
         <p:nvSpPr>
-          <p:cNvPr id="21" name="Text 18"/>
+          <p:cNvPr id="23" name="Text 20"/>
           <p:cNvSpPr txBox="1"/>
           <p:nvPr/>
         </p:nvSpPr>
@@ -6708,7 +7131,7 @@
       </p:sp>
       <p:sp>
         <p:nvSpPr>
-          <p:cNvPr id="22" name="Text 19"/>
+          <p:cNvPr id="24" name="Text 21"/>
           <p:cNvSpPr txBox="1"/>
           <p:nvPr/>
         </p:nvSpPr>
@@ -8350,8 +8773,8 @@
         </p:nvSpPr>
         <p:spPr>
           <a:xfrm>
-            <a:off x="548640" y="3429000"/>
-            <a:ext cx="457200" cy="256032"/>
+            <a:off x="548640" y="3108960"/>
+            <a:ext cx="457200" cy="246888"/>
           </a:xfrm>
           <a:prstGeom prst="rect">
             <a:avLst/>
@@ -8389,8 +8812,8 @@
         </p:nvSpPr>
         <p:spPr>
           <a:xfrm>
-            <a:off x="1005840" y="3429000"/>
-            <a:ext cx="2743200" cy="256032"/>
+            <a:off x="1005840" y="3108960"/>
+            <a:ext cx="2743200" cy="246888"/>
           </a:xfrm>
           <a:prstGeom prst="rect">
             <a:avLst/>
@@ -8428,8 +8851,8 @@
         </p:nvSpPr>
         <p:spPr>
           <a:xfrm>
-            <a:off x="548640" y="3685032"/>
-            <a:ext cx="457200" cy="256032"/>
+            <a:off x="548640" y="3355848"/>
+            <a:ext cx="457200" cy="246888"/>
           </a:xfrm>
           <a:prstGeom prst="rect">
             <a:avLst/>
@@ -8467,8 +8890,8 @@
         </p:nvSpPr>
         <p:spPr>
           <a:xfrm>
-            <a:off x="1005840" y="3685032"/>
-            <a:ext cx="2743200" cy="256032"/>
+            <a:off x="1005840" y="3355848"/>
+            <a:ext cx="2743200" cy="246888"/>
           </a:xfrm>
           <a:prstGeom prst="rect">
             <a:avLst/>
@@ -8506,8 +8929,8 @@
         </p:nvSpPr>
         <p:spPr>
           <a:xfrm>
-            <a:off x="548640" y="3941064"/>
-            <a:ext cx="457200" cy="256032"/>
+            <a:off x="548640" y="3602736"/>
+            <a:ext cx="457200" cy="246888"/>
           </a:xfrm>
           <a:prstGeom prst="rect">
             <a:avLst/>
@@ -8545,8 +8968,8 @@
         </p:nvSpPr>
         <p:spPr>
           <a:xfrm>
-            <a:off x="1005840" y="3941064"/>
-            <a:ext cx="2743200" cy="256032"/>
+            <a:off x="1005840" y="3602736"/>
+            <a:ext cx="2743200" cy="246888"/>
           </a:xfrm>
           <a:prstGeom prst="rect">
             <a:avLst/>
@@ -8584,8 +9007,8 @@
         </p:nvSpPr>
         <p:spPr>
           <a:xfrm>
-            <a:off x="548640" y="4197096"/>
-            <a:ext cx="457200" cy="256032"/>
+            <a:off x="548640" y="3849624"/>
+            <a:ext cx="457200" cy="246888"/>
           </a:xfrm>
           <a:prstGeom prst="rect">
             <a:avLst/>
@@ -8623,8 +9046,8 @@
         </p:nvSpPr>
         <p:spPr>
           <a:xfrm>
-            <a:off x="1005840" y="4197096"/>
-            <a:ext cx="2743200" cy="256032"/>
+            <a:off x="1005840" y="3849624"/>
+            <a:ext cx="2743200" cy="246888"/>
           </a:xfrm>
           <a:prstGeom prst="rect">
             <a:avLst/>
@@ -8662,8 +9085,8 @@
         </p:nvSpPr>
         <p:spPr>
           <a:xfrm>
-            <a:off x="548640" y="4453128"/>
-            <a:ext cx="457200" cy="256032"/>
+            <a:off x="548640" y="4096512"/>
+            <a:ext cx="457200" cy="246888"/>
           </a:xfrm>
           <a:prstGeom prst="rect">
             <a:avLst/>
@@ -8701,8 +9124,8 @@
         </p:nvSpPr>
         <p:spPr>
           <a:xfrm>
-            <a:off x="1005840" y="4453128"/>
-            <a:ext cx="2743200" cy="256032"/>
+            <a:off x="1005840" y="4096512"/>
+            <a:ext cx="2743200" cy="246888"/>
           </a:xfrm>
           <a:prstGeom prst="rect">
             <a:avLst/>
@@ -8734,7 +9157,85 @@
       </p:sp>
       <p:sp>
         <p:nvSpPr>
-          <p:cNvPr id="16" name="Shape 13"/>
+          <p:cNvPr id="16" name="Text 13"/>
+          <p:cNvSpPr txBox="1"/>
+          <p:nvPr/>
+        </p:nvSpPr>
+        <p:spPr>
+          <a:xfrm>
+            <a:off x="548640" y="4343400"/>
+            <a:ext cx="457200" cy="246888"/>
+          </a:xfrm>
+          <a:prstGeom prst="rect">
+            <a:avLst/>
+          </a:prstGeom>
+          <a:noFill/>
+          <a:ln/>
+        </p:spPr>
+        <p:txBody>
+          <a:bodyPr wrap="square" lIns="0" tIns="0" rIns="0" bIns="0" rtlCol="0" anchor="ctr"/>
+          <a:lstStyle/>
+          <a:p>
+            <a:pPr indent="0" marL="0">
+              <a:buNone/>
+            </a:pPr>
+            <a:r>
+              <a:rPr lang="en-US" sz="1200" b="1" dirty="0">
+                <a:solidFill>
+                  <a:srgbClr val="595959"/>
+                </a:solidFill>
+                <a:latin typeface="Arial" pitchFamily="34" charset="0"/>
+                <a:ea typeface="Arial" pitchFamily="34" charset="-122"/>
+                <a:cs typeface="Arial" pitchFamily="34" charset="-120"/>
+              </a:rPr>
+              <a:t>06</a:t>
+            </a:r>
+            <a:endParaRPr lang="en-US" sz="1200" dirty="0"/>
+          </a:p>
+        </p:txBody>
+      </p:sp>
+      <p:sp>
+        <p:nvSpPr>
+          <p:cNvPr id="17" name="Text 14"/>
+          <p:cNvSpPr txBox="1"/>
+          <p:nvPr/>
+        </p:nvSpPr>
+        <p:spPr>
+          <a:xfrm>
+            <a:off x="1005840" y="4343400"/>
+            <a:ext cx="2743200" cy="246888"/>
+          </a:xfrm>
+          <a:prstGeom prst="rect">
+            <a:avLst/>
+          </a:prstGeom>
+          <a:noFill/>
+          <a:ln/>
+        </p:spPr>
+        <p:txBody>
+          <a:bodyPr wrap="square" lIns="0" tIns="0" rIns="0" bIns="0" rtlCol="0" anchor="ctr"/>
+          <a:lstStyle/>
+          <a:p>
+            <a:pPr indent="0" marL="0">
+              <a:buNone/>
+            </a:pPr>
+            <a:r>
+              <a:rPr lang="en-US" sz="1200" dirty="0">
+                <a:solidFill>
+                  <a:srgbClr val="595959"/>
+                </a:solidFill>
+                <a:latin typeface="Arial" pitchFamily="34" charset="0"/>
+                <a:ea typeface="Arial" pitchFamily="34" charset="-122"/>
+                <a:cs typeface="Arial" pitchFamily="34" charset="-120"/>
+              </a:rPr>
+              <a:t>Implement</a:t>
+            </a:r>
+            <a:endParaRPr lang="en-US" sz="1200" dirty="0"/>
+          </a:p>
+        </p:txBody>
+      </p:sp>
+      <p:sp>
+        <p:nvSpPr>
+          <p:cNvPr id="18" name="Shape 15"/>
           <p:cNvSpPr/>
           <p:nvPr/>
         </p:nvSpPr>
@@ -8759,7 +9260,7 @@
       </p:sp>
       <p:sp>
         <p:nvSpPr>
-          <p:cNvPr id="17" name="Text 14"/>
+          <p:cNvPr id="19" name="Text 16"/>
           <p:cNvSpPr txBox="1"/>
           <p:nvPr/>
         </p:nvSpPr>
@@ -8798,7 +9299,7 @@
       </p:sp>
       <p:sp>
         <p:nvSpPr>
-          <p:cNvPr id="18" name="Text 15"/>
+          <p:cNvPr id="20" name="Text 17"/>
           <p:cNvSpPr txBox="1"/>
           <p:nvPr/>
         </p:nvSpPr>
@@ -8837,7 +9338,7 @@
       </p:sp>
       <p:sp>
         <p:nvSpPr>
-          <p:cNvPr id="19" name="Text 16"/>
+          <p:cNvPr id="21" name="Text 18"/>
           <p:cNvSpPr txBox="1"/>
           <p:nvPr/>
         </p:nvSpPr>
@@ -8876,7 +9377,7 @@
       </p:sp>
       <p:sp>
         <p:nvSpPr>
-          <p:cNvPr id="20" name="Text 17"/>
+          <p:cNvPr id="22" name="Text 19"/>
           <p:cNvSpPr txBox="1"/>
           <p:nvPr/>
         </p:nvSpPr>
@@ -8915,7 +9416,7 @@
       </p:sp>
       <p:sp>
         <p:nvSpPr>
-          <p:cNvPr id="21" name="Text 18"/>
+          <p:cNvPr id="23" name="Text 20"/>
           <p:cNvSpPr txBox="1"/>
           <p:nvPr/>
         </p:nvSpPr>
@@ -8954,7 +9455,7 @@
       </p:sp>
       <p:sp>
         <p:nvSpPr>
-          <p:cNvPr id="22" name="Text 19"/>
+          <p:cNvPr id="24" name="Text 21"/>
           <p:cNvSpPr txBox="1"/>
           <p:nvPr/>
         </p:nvSpPr>
@@ -12439,6 +12940,882 @@
     <p:bg>
       <p:bgPr>
         <a:solidFill>
+          <a:srgbClr val="000000"/>
+        </a:solidFill>
+      </p:bgPr>
+    </p:bg>
+    <p:spTree>
+      <p:nvGrpSpPr>
+        <p:cNvPr id="1" name=""/>
+        <p:cNvGrpSpPr/>
+        <p:nvPr/>
+      </p:nvGrpSpPr>
+      <p:grpSpPr>
+        <a:xfrm>
+          <a:off x="0" y="0"/>
+          <a:ext cx="0" cy="0"/>
+          <a:chOff x="0" y="0"/>
+          <a:chExt cx="0" cy="0"/>
+        </a:xfrm>
+      </p:grpSpPr>
+      <p:sp>
+        <p:nvSpPr>
+          <p:cNvPr id="3" name="Text 0"/>
+          <p:cNvSpPr txBox="1"/>
+          <p:nvPr/>
+        </p:nvSpPr>
+        <p:spPr>
+          <a:xfrm>
+            <a:off x="548640" y="457200"/>
+            <a:ext cx="2743200" cy="1280160"/>
+          </a:xfrm>
+          <a:prstGeom prst="rect">
+            <a:avLst/>
+          </a:prstGeom>
+          <a:noFill/>
+          <a:ln/>
+        </p:spPr>
+        <p:txBody>
+          <a:bodyPr wrap="square" lIns="0" tIns="0" rIns="0" bIns="0" rtlCol="0" anchor="b"/>
+          <a:lstStyle/>
+          <a:p>
+            <a:pPr indent="0" marL="0">
+              <a:buNone/>
+            </a:pPr>
+            <a:r>
+              <a:rPr lang="en-US" sz="9600" b="1" dirty="0">
+                <a:solidFill>
+                  <a:srgbClr val="FFFFFF"/>
+                </a:solidFill>
+                <a:latin typeface="Arial" pitchFamily="34" charset="0"/>
+                <a:ea typeface="Arial" pitchFamily="34" charset="-122"/>
+                <a:cs typeface="Arial" pitchFamily="34" charset="-120"/>
+              </a:rPr>
+              <a:t>06</a:t>
+            </a:r>
+            <a:endParaRPr lang="en-US" sz="9600" dirty="0"/>
+          </a:p>
+        </p:txBody>
+      </p:sp>
+      <p:sp>
+        <p:nvSpPr>
+          <p:cNvPr id="4" name="Text 1"/>
+          <p:cNvSpPr txBox="1"/>
+          <p:nvPr/>
+        </p:nvSpPr>
+        <p:spPr>
+          <a:xfrm>
+            <a:off x="548640" y="1783080"/>
+            <a:ext cx="3657600" cy="640080"/>
+          </a:xfrm>
+          <a:prstGeom prst="rect">
+            <a:avLst/>
+          </a:prstGeom>
+          <a:noFill/>
+          <a:ln/>
+        </p:spPr>
+        <p:txBody>
+          <a:bodyPr wrap="square" lIns="0" tIns="0" rIns="0" bIns="0" rtlCol="0" anchor="ctr"/>
+          <a:lstStyle/>
+          <a:p>
+            <a:pPr indent="0" marL="0">
+              <a:buNone/>
+            </a:pPr>
+            <a:r>
+              <a:rPr lang="en-US" sz="4000" b="1" dirty="0">
+                <a:solidFill>
+                  <a:srgbClr val="FFFFFF"/>
+                </a:solidFill>
+                <a:latin typeface="Arial" pitchFamily="34" charset="0"/>
+                <a:ea typeface="Arial" pitchFamily="34" charset="-122"/>
+                <a:cs typeface="Arial" pitchFamily="34" charset="-120"/>
+              </a:rPr>
+              <a:t>Implement</a:t>
+            </a:r>
+            <a:endParaRPr lang="en-US" sz="4000" dirty="0"/>
+          </a:p>
+        </p:txBody>
+      </p:sp>
+      <p:sp>
+        <p:nvSpPr>
+          <p:cNvPr id="5" name="Text 2"/>
+          <p:cNvSpPr txBox="1"/>
+          <p:nvPr/>
+        </p:nvSpPr>
+        <p:spPr>
+          <a:xfrm>
+            <a:off x="548640" y="2560320"/>
+            <a:ext cx="3474720" cy="640080"/>
+          </a:xfrm>
+          <a:prstGeom prst="rect">
+            <a:avLst/>
+          </a:prstGeom>
+          <a:noFill/>
+          <a:ln/>
+        </p:spPr>
+        <p:txBody>
+          <a:bodyPr wrap="square" lIns="0" tIns="0" rIns="0" bIns="0" rtlCol="0" anchor="t"/>
+          <a:lstStyle/>
+          <a:p>
+            <a:pPr indent="0" marL="0">
+              <a:buNone/>
+            </a:pPr>
+            <a:r>
+              <a:rPr lang="en-US" sz="1600" i="1" dirty="0">
+                <a:solidFill>
+                  <a:srgbClr val="BFBFBF"/>
+                </a:solidFill>
+                <a:latin typeface="Arial" pitchFamily="34" charset="0"/>
+                <a:ea typeface="Arial" pitchFamily="34" charset="-122"/>
+                <a:cs typeface="Arial" pitchFamily="34" charset="-120"/>
+              </a:rPr>
+              <a:t>Build it, then put it to use.</a:t>
+            </a:r>
+            <a:endParaRPr lang="en-US" sz="1600" dirty="0"/>
+          </a:p>
+        </p:txBody>
+      </p:sp>
+      <p:sp>
+        <p:nvSpPr>
+          <p:cNvPr id="6" name="Text 3"/>
+          <p:cNvSpPr txBox="1"/>
+          <p:nvPr/>
+        </p:nvSpPr>
+        <p:spPr>
+          <a:xfrm>
+            <a:off x="548640" y="3108960"/>
+            <a:ext cx="457200" cy="246888"/>
+          </a:xfrm>
+          <a:prstGeom prst="rect">
+            <a:avLst/>
+          </a:prstGeom>
+          <a:noFill/>
+          <a:ln/>
+        </p:spPr>
+        <p:txBody>
+          <a:bodyPr wrap="square" lIns="0" tIns="0" rIns="0" bIns="0" rtlCol="0" anchor="ctr"/>
+          <a:lstStyle/>
+          <a:p>
+            <a:pPr indent="0" marL="0">
+              <a:buNone/>
+            </a:pPr>
+            <a:r>
+              <a:rPr lang="en-US" sz="1200" b="1" dirty="0">
+                <a:solidFill>
+                  <a:srgbClr val="595959"/>
+                </a:solidFill>
+                <a:latin typeface="Arial" pitchFamily="34" charset="0"/>
+                <a:ea typeface="Arial" pitchFamily="34" charset="-122"/>
+                <a:cs typeface="Arial" pitchFamily="34" charset="-120"/>
+              </a:rPr>
+              <a:t>01</a:t>
+            </a:r>
+            <a:endParaRPr lang="en-US" sz="1200" dirty="0"/>
+          </a:p>
+        </p:txBody>
+      </p:sp>
+      <p:sp>
+        <p:nvSpPr>
+          <p:cNvPr id="7" name="Text 4"/>
+          <p:cNvSpPr txBox="1"/>
+          <p:nvPr/>
+        </p:nvSpPr>
+        <p:spPr>
+          <a:xfrm>
+            <a:off x="1005840" y="3108960"/>
+            <a:ext cx="2743200" cy="246888"/>
+          </a:xfrm>
+          <a:prstGeom prst="rect">
+            <a:avLst/>
+          </a:prstGeom>
+          <a:noFill/>
+          <a:ln/>
+        </p:spPr>
+        <p:txBody>
+          <a:bodyPr wrap="square" lIns="0" tIns="0" rIns="0" bIns="0" rtlCol="0" anchor="ctr"/>
+          <a:lstStyle/>
+          <a:p>
+            <a:pPr indent="0" marL="0">
+              <a:buNone/>
+            </a:pPr>
+            <a:r>
+              <a:rPr lang="en-US" sz="1200" dirty="0">
+                <a:solidFill>
+                  <a:srgbClr val="595959"/>
+                </a:solidFill>
+                <a:latin typeface="Arial" pitchFamily="34" charset="0"/>
+                <a:ea typeface="Arial" pitchFamily="34" charset="-122"/>
+                <a:cs typeface="Arial" pitchFamily="34" charset="-120"/>
+              </a:rPr>
+              <a:t>Empathize</a:t>
+            </a:r>
+            <a:endParaRPr lang="en-US" sz="1200" dirty="0"/>
+          </a:p>
+        </p:txBody>
+      </p:sp>
+      <p:sp>
+        <p:nvSpPr>
+          <p:cNvPr id="8" name="Text 5"/>
+          <p:cNvSpPr txBox="1"/>
+          <p:nvPr/>
+        </p:nvSpPr>
+        <p:spPr>
+          <a:xfrm>
+            <a:off x="548640" y="3355848"/>
+            <a:ext cx="457200" cy="246888"/>
+          </a:xfrm>
+          <a:prstGeom prst="rect">
+            <a:avLst/>
+          </a:prstGeom>
+          <a:noFill/>
+          <a:ln/>
+        </p:spPr>
+        <p:txBody>
+          <a:bodyPr wrap="square" lIns="0" tIns="0" rIns="0" bIns="0" rtlCol="0" anchor="ctr"/>
+          <a:lstStyle/>
+          <a:p>
+            <a:pPr indent="0" marL="0">
+              <a:buNone/>
+            </a:pPr>
+            <a:r>
+              <a:rPr lang="en-US" sz="1200" b="1" dirty="0">
+                <a:solidFill>
+                  <a:srgbClr val="595959"/>
+                </a:solidFill>
+                <a:latin typeface="Arial" pitchFamily="34" charset="0"/>
+                <a:ea typeface="Arial" pitchFamily="34" charset="-122"/>
+                <a:cs typeface="Arial" pitchFamily="34" charset="-120"/>
+              </a:rPr>
+              <a:t>02</a:t>
+            </a:r>
+            <a:endParaRPr lang="en-US" sz="1200" dirty="0"/>
+          </a:p>
+        </p:txBody>
+      </p:sp>
+      <p:sp>
+        <p:nvSpPr>
+          <p:cNvPr id="9" name="Text 6"/>
+          <p:cNvSpPr txBox="1"/>
+          <p:nvPr/>
+        </p:nvSpPr>
+        <p:spPr>
+          <a:xfrm>
+            <a:off x="1005840" y="3355848"/>
+            <a:ext cx="2743200" cy="246888"/>
+          </a:xfrm>
+          <a:prstGeom prst="rect">
+            <a:avLst/>
+          </a:prstGeom>
+          <a:noFill/>
+          <a:ln/>
+        </p:spPr>
+        <p:txBody>
+          <a:bodyPr wrap="square" lIns="0" tIns="0" rIns="0" bIns="0" rtlCol="0" anchor="ctr"/>
+          <a:lstStyle/>
+          <a:p>
+            <a:pPr indent="0" marL="0">
+              <a:buNone/>
+            </a:pPr>
+            <a:r>
+              <a:rPr lang="en-US" sz="1200" dirty="0">
+                <a:solidFill>
+                  <a:srgbClr val="595959"/>
+                </a:solidFill>
+                <a:latin typeface="Arial" pitchFamily="34" charset="0"/>
+                <a:ea typeface="Arial" pitchFamily="34" charset="-122"/>
+                <a:cs typeface="Arial" pitchFamily="34" charset="-120"/>
+              </a:rPr>
+              <a:t>Define</a:t>
+            </a:r>
+            <a:endParaRPr lang="en-US" sz="1200" dirty="0"/>
+          </a:p>
+        </p:txBody>
+      </p:sp>
+      <p:sp>
+        <p:nvSpPr>
+          <p:cNvPr id="10" name="Text 7"/>
+          <p:cNvSpPr txBox="1"/>
+          <p:nvPr/>
+        </p:nvSpPr>
+        <p:spPr>
+          <a:xfrm>
+            <a:off x="548640" y="3602736"/>
+            <a:ext cx="457200" cy="246888"/>
+          </a:xfrm>
+          <a:prstGeom prst="rect">
+            <a:avLst/>
+          </a:prstGeom>
+          <a:noFill/>
+          <a:ln/>
+        </p:spPr>
+        <p:txBody>
+          <a:bodyPr wrap="square" lIns="0" tIns="0" rIns="0" bIns="0" rtlCol="0" anchor="ctr"/>
+          <a:lstStyle/>
+          <a:p>
+            <a:pPr indent="0" marL="0">
+              <a:buNone/>
+            </a:pPr>
+            <a:r>
+              <a:rPr lang="en-US" sz="1200" b="1" dirty="0">
+                <a:solidFill>
+                  <a:srgbClr val="595959"/>
+                </a:solidFill>
+                <a:latin typeface="Arial" pitchFamily="34" charset="0"/>
+                <a:ea typeface="Arial" pitchFamily="34" charset="-122"/>
+                <a:cs typeface="Arial" pitchFamily="34" charset="-120"/>
+              </a:rPr>
+              <a:t>03</a:t>
+            </a:r>
+            <a:endParaRPr lang="en-US" sz="1200" dirty="0"/>
+          </a:p>
+        </p:txBody>
+      </p:sp>
+      <p:sp>
+        <p:nvSpPr>
+          <p:cNvPr id="11" name="Text 8"/>
+          <p:cNvSpPr txBox="1"/>
+          <p:nvPr/>
+        </p:nvSpPr>
+        <p:spPr>
+          <a:xfrm>
+            <a:off x="1005840" y="3602736"/>
+            <a:ext cx="2743200" cy="246888"/>
+          </a:xfrm>
+          <a:prstGeom prst="rect">
+            <a:avLst/>
+          </a:prstGeom>
+          <a:noFill/>
+          <a:ln/>
+        </p:spPr>
+        <p:txBody>
+          <a:bodyPr wrap="square" lIns="0" tIns="0" rIns="0" bIns="0" rtlCol="0" anchor="ctr"/>
+          <a:lstStyle/>
+          <a:p>
+            <a:pPr indent="0" marL="0">
+              <a:buNone/>
+            </a:pPr>
+            <a:r>
+              <a:rPr lang="en-US" sz="1200" dirty="0">
+                <a:solidFill>
+                  <a:srgbClr val="595959"/>
+                </a:solidFill>
+                <a:latin typeface="Arial" pitchFamily="34" charset="0"/>
+                <a:ea typeface="Arial" pitchFamily="34" charset="-122"/>
+                <a:cs typeface="Arial" pitchFamily="34" charset="-120"/>
+              </a:rPr>
+              <a:t>Ideate</a:t>
+            </a:r>
+            <a:endParaRPr lang="en-US" sz="1200" dirty="0"/>
+          </a:p>
+        </p:txBody>
+      </p:sp>
+      <p:sp>
+        <p:nvSpPr>
+          <p:cNvPr id="12" name="Text 9"/>
+          <p:cNvSpPr txBox="1"/>
+          <p:nvPr/>
+        </p:nvSpPr>
+        <p:spPr>
+          <a:xfrm>
+            <a:off x="548640" y="3849624"/>
+            <a:ext cx="457200" cy="246888"/>
+          </a:xfrm>
+          <a:prstGeom prst="rect">
+            <a:avLst/>
+          </a:prstGeom>
+          <a:noFill/>
+          <a:ln/>
+        </p:spPr>
+        <p:txBody>
+          <a:bodyPr wrap="square" lIns="0" tIns="0" rIns="0" bIns="0" rtlCol="0" anchor="ctr"/>
+          <a:lstStyle/>
+          <a:p>
+            <a:pPr indent="0" marL="0">
+              <a:buNone/>
+            </a:pPr>
+            <a:r>
+              <a:rPr lang="en-US" sz="1200" b="1" dirty="0">
+                <a:solidFill>
+                  <a:srgbClr val="595959"/>
+                </a:solidFill>
+                <a:latin typeface="Arial" pitchFamily="34" charset="0"/>
+                <a:ea typeface="Arial" pitchFamily="34" charset="-122"/>
+                <a:cs typeface="Arial" pitchFamily="34" charset="-120"/>
+              </a:rPr>
+              <a:t>04</a:t>
+            </a:r>
+            <a:endParaRPr lang="en-US" sz="1200" dirty="0"/>
+          </a:p>
+        </p:txBody>
+      </p:sp>
+      <p:sp>
+        <p:nvSpPr>
+          <p:cNvPr id="13" name="Text 10"/>
+          <p:cNvSpPr txBox="1"/>
+          <p:nvPr/>
+        </p:nvSpPr>
+        <p:spPr>
+          <a:xfrm>
+            <a:off x="1005840" y="3849624"/>
+            <a:ext cx="2743200" cy="246888"/>
+          </a:xfrm>
+          <a:prstGeom prst="rect">
+            <a:avLst/>
+          </a:prstGeom>
+          <a:noFill/>
+          <a:ln/>
+        </p:spPr>
+        <p:txBody>
+          <a:bodyPr wrap="square" lIns="0" tIns="0" rIns="0" bIns="0" rtlCol="0" anchor="ctr"/>
+          <a:lstStyle/>
+          <a:p>
+            <a:pPr indent="0" marL="0">
+              <a:buNone/>
+            </a:pPr>
+            <a:r>
+              <a:rPr lang="en-US" sz="1200" dirty="0">
+                <a:solidFill>
+                  <a:srgbClr val="595959"/>
+                </a:solidFill>
+                <a:latin typeface="Arial" pitchFamily="34" charset="0"/>
+                <a:ea typeface="Arial" pitchFamily="34" charset="-122"/>
+                <a:cs typeface="Arial" pitchFamily="34" charset="-120"/>
+              </a:rPr>
+              <a:t>Prototype</a:t>
+            </a:r>
+            <a:endParaRPr lang="en-US" sz="1200" dirty="0"/>
+          </a:p>
+        </p:txBody>
+      </p:sp>
+      <p:sp>
+        <p:nvSpPr>
+          <p:cNvPr id="14" name="Text 11"/>
+          <p:cNvSpPr txBox="1"/>
+          <p:nvPr/>
+        </p:nvSpPr>
+        <p:spPr>
+          <a:xfrm>
+            <a:off x="548640" y="4096512"/>
+            <a:ext cx="457200" cy="246888"/>
+          </a:xfrm>
+          <a:prstGeom prst="rect">
+            <a:avLst/>
+          </a:prstGeom>
+          <a:noFill/>
+          <a:ln/>
+        </p:spPr>
+        <p:txBody>
+          <a:bodyPr wrap="square" lIns="0" tIns="0" rIns="0" bIns="0" rtlCol="0" anchor="ctr"/>
+          <a:lstStyle/>
+          <a:p>
+            <a:pPr indent="0" marL="0">
+              <a:buNone/>
+            </a:pPr>
+            <a:r>
+              <a:rPr lang="en-US" sz="1200" b="1" dirty="0">
+                <a:solidFill>
+                  <a:srgbClr val="595959"/>
+                </a:solidFill>
+                <a:latin typeface="Arial" pitchFamily="34" charset="0"/>
+                <a:ea typeface="Arial" pitchFamily="34" charset="-122"/>
+                <a:cs typeface="Arial" pitchFamily="34" charset="-120"/>
+              </a:rPr>
+              <a:t>05</a:t>
+            </a:r>
+            <a:endParaRPr lang="en-US" sz="1200" dirty="0"/>
+          </a:p>
+        </p:txBody>
+      </p:sp>
+      <p:sp>
+        <p:nvSpPr>
+          <p:cNvPr id="15" name="Text 12"/>
+          <p:cNvSpPr txBox="1"/>
+          <p:nvPr/>
+        </p:nvSpPr>
+        <p:spPr>
+          <a:xfrm>
+            <a:off x="1005840" y="4096512"/>
+            <a:ext cx="2743200" cy="246888"/>
+          </a:xfrm>
+          <a:prstGeom prst="rect">
+            <a:avLst/>
+          </a:prstGeom>
+          <a:noFill/>
+          <a:ln/>
+        </p:spPr>
+        <p:txBody>
+          <a:bodyPr wrap="square" lIns="0" tIns="0" rIns="0" bIns="0" rtlCol="0" anchor="ctr"/>
+          <a:lstStyle/>
+          <a:p>
+            <a:pPr indent="0" marL="0">
+              <a:buNone/>
+            </a:pPr>
+            <a:r>
+              <a:rPr lang="en-US" sz="1200" dirty="0">
+                <a:solidFill>
+                  <a:srgbClr val="595959"/>
+                </a:solidFill>
+                <a:latin typeface="Arial" pitchFamily="34" charset="0"/>
+                <a:ea typeface="Arial" pitchFamily="34" charset="-122"/>
+                <a:cs typeface="Arial" pitchFamily="34" charset="-120"/>
+              </a:rPr>
+              <a:t>Test</a:t>
+            </a:r>
+            <a:endParaRPr lang="en-US" sz="1200" dirty="0"/>
+          </a:p>
+        </p:txBody>
+      </p:sp>
+      <p:sp>
+        <p:nvSpPr>
+          <p:cNvPr id="16" name="Text 13"/>
+          <p:cNvSpPr txBox="1"/>
+          <p:nvPr/>
+        </p:nvSpPr>
+        <p:spPr>
+          <a:xfrm>
+            <a:off x="548640" y="4343400"/>
+            <a:ext cx="457200" cy="246888"/>
+          </a:xfrm>
+          <a:prstGeom prst="rect">
+            <a:avLst/>
+          </a:prstGeom>
+          <a:noFill/>
+          <a:ln/>
+        </p:spPr>
+        <p:txBody>
+          <a:bodyPr wrap="square" lIns="0" tIns="0" rIns="0" bIns="0" rtlCol="0" anchor="ctr"/>
+          <a:lstStyle/>
+          <a:p>
+            <a:pPr indent="0" marL="0">
+              <a:buNone/>
+            </a:pPr>
+            <a:r>
+              <a:rPr lang="en-US" sz="1200" b="1" dirty="0">
+                <a:solidFill>
+                  <a:srgbClr val="FFFFFF"/>
+                </a:solidFill>
+                <a:latin typeface="Arial" pitchFamily="34" charset="0"/>
+                <a:ea typeface="Arial" pitchFamily="34" charset="-122"/>
+                <a:cs typeface="Arial" pitchFamily="34" charset="-120"/>
+              </a:rPr>
+              <a:t>06</a:t>
+            </a:r>
+            <a:endParaRPr lang="en-US" sz="1200" dirty="0"/>
+          </a:p>
+        </p:txBody>
+      </p:sp>
+      <p:sp>
+        <p:nvSpPr>
+          <p:cNvPr id="17" name="Text 14"/>
+          <p:cNvSpPr txBox="1"/>
+          <p:nvPr/>
+        </p:nvSpPr>
+        <p:spPr>
+          <a:xfrm>
+            <a:off x="1005840" y="4343400"/>
+            <a:ext cx="2743200" cy="246888"/>
+          </a:xfrm>
+          <a:prstGeom prst="rect">
+            <a:avLst/>
+          </a:prstGeom>
+          <a:noFill/>
+          <a:ln/>
+        </p:spPr>
+        <p:txBody>
+          <a:bodyPr wrap="square" lIns="0" tIns="0" rIns="0" bIns="0" rtlCol="0" anchor="ctr"/>
+          <a:lstStyle/>
+          <a:p>
+            <a:pPr indent="0" marL="0">
+              <a:buNone/>
+            </a:pPr>
+            <a:r>
+              <a:rPr lang="en-US" sz="1200" b="1" dirty="0">
+                <a:solidFill>
+                  <a:srgbClr val="FFFFFF"/>
+                </a:solidFill>
+                <a:latin typeface="Arial" pitchFamily="34" charset="0"/>
+                <a:ea typeface="Arial" pitchFamily="34" charset="-122"/>
+                <a:cs typeface="Arial" pitchFamily="34" charset="-120"/>
+              </a:rPr>
+              <a:t>Implement</a:t>
+            </a:r>
+            <a:endParaRPr lang="en-US" sz="1200" dirty="0"/>
+          </a:p>
+        </p:txBody>
+      </p:sp>
+      <p:sp>
+        <p:nvSpPr>
+          <p:cNvPr id="18" name="Shape 15"/>
+          <p:cNvSpPr/>
+          <p:nvPr/>
+        </p:nvSpPr>
+        <p:spPr>
+          <a:xfrm>
+            <a:off x="4480560" y="457200"/>
+            <a:ext cx="4206240" cy="4206240"/>
+          </a:xfrm>
+          <a:prstGeom prst="rect">
+            <a:avLst/>
+          </a:prstGeom>
+          <a:solidFill>
+            <a:srgbClr val="FFFFFF"/>
+          </a:solidFill>
+          <a:ln w="12700">
+            <a:solidFill>
+              <a:srgbClr val="FFFFFF"/>
+            </a:solidFill>
+            <a:prstDash val="solid"/>
+          </a:ln>
+        </p:spPr>
+      </p:sp>
+      <p:sp>
+        <p:nvSpPr>
+          <p:cNvPr id="19" name="Text 16"/>
+          <p:cNvSpPr txBox="1"/>
+          <p:nvPr/>
+        </p:nvSpPr>
+        <p:spPr>
+          <a:xfrm>
+            <a:off x="4754880" y="685800"/>
+            <a:ext cx="3657600" cy="256032"/>
+          </a:xfrm>
+          <a:prstGeom prst="rect">
+            <a:avLst/>
+          </a:prstGeom>
+          <a:noFill/>
+          <a:ln/>
+        </p:spPr>
+        <p:txBody>
+          <a:bodyPr wrap="square" lIns="0" tIns="0" rIns="0" bIns="0" rtlCol="0" anchor="ctr"/>
+          <a:lstStyle/>
+          <a:p>
+            <a:pPr indent="0" marL="0">
+              <a:buNone/>
+            </a:pPr>
+            <a:r>
+              <a:rPr lang="en-US" sz="1100" b="1" spc="200" kern="0" dirty="0">
+                <a:solidFill>
+                  <a:srgbClr val="8C8C8C"/>
+                </a:solidFill>
+                <a:latin typeface="Arial" pitchFamily="34" charset="0"/>
+                <a:ea typeface="Arial" pitchFamily="34" charset="-122"/>
+                <a:cs typeface="Arial" pitchFamily="34" charset="-120"/>
+              </a:rPr>
+              <a:t>WHAT IT MEANS</a:t>
+            </a:r>
+            <a:endParaRPr lang="en-US" sz="1100" dirty="0"/>
+          </a:p>
+        </p:txBody>
+      </p:sp>
+      <p:sp>
+        <p:nvSpPr>
+          <p:cNvPr id="20" name="Text 17"/>
+          <p:cNvSpPr txBox="1"/>
+          <p:nvPr/>
+        </p:nvSpPr>
+        <p:spPr>
+          <a:xfrm>
+            <a:off x="4754880" y="978408"/>
+            <a:ext cx="3657600" cy="1005840"/>
+          </a:xfrm>
+          <a:prstGeom prst="rect">
+            <a:avLst/>
+          </a:prstGeom>
+          <a:noFill/>
+          <a:ln/>
+        </p:spPr>
+        <p:txBody>
+          <a:bodyPr wrap="square" lIns="0" tIns="0" rIns="0" bIns="0" rtlCol="0" anchor="t"/>
+          <a:lstStyle/>
+          <a:p>
+            <a:pPr indent="0" marL="0">
+              <a:buNone/>
+            </a:pPr>
+            <a:r>
+              <a:rPr lang="en-US" sz="1500" dirty="0">
+                <a:solidFill>
+                  <a:srgbClr val="000000"/>
+                </a:solidFill>
+                <a:latin typeface="Arial" pitchFamily="34" charset="0"/>
+                <a:ea typeface="Arial" pitchFamily="34" charset="-122"/>
+                <a:cs typeface="Arial" pitchFamily="34" charset="-120"/>
+              </a:rPr>
+              <a:t>Put the solution into real hands and make it easy to start. Plan how it reaches the people it was built for.</a:t>
+            </a:r>
+            <a:endParaRPr lang="en-US" sz="1500" dirty="0"/>
+          </a:p>
+        </p:txBody>
+      </p:sp>
+      <p:sp>
+        <p:nvSpPr>
+          <p:cNvPr id="21" name="Text 18"/>
+          <p:cNvSpPr txBox="1"/>
+          <p:nvPr/>
+        </p:nvSpPr>
+        <p:spPr>
+          <a:xfrm>
+            <a:off x="4754880" y="2057400"/>
+            <a:ext cx="3657600" cy="256032"/>
+          </a:xfrm>
+          <a:prstGeom prst="rect">
+            <a:avLst/>
+          </a:prstGeom>
+          <a:noFill/>
+          <a:ln/>
+        </p:spPr>
+        <p:txBody>
+          <a:bodyPr wrap="square" lIns="0" tIns="0" rIns="0" bIns="0" rtlCol="0" anchor="ctr"/>
+          <a:lstStyle/>
+          <a:p>
+            <a:pPr indent="0" marL="0">
+              <a:buNone/>
+            </a:pPr>
+            <a:r>
+              <a:rPr lang="en-US" sz="1100" b="1" spc="200" kern="0" dirty="0">
+                <a:solidFill>
+                  <a:srgbClr val="8C8C8C"/>
+                </a:solidFill>
+                <a:latin typeface="Arial" pitchFamily="34" charset="0"/>
+                <a:ea typeface="Arial" pitchFamily="34" charset="-122"/>
+                <a:cs typeface="Arial" pitchFamily="34" charset="-120"/>
+              </a:rPr>
+              <a:t>THE QUESTION IT ASKS</a:t>
+            </a:r>
+            <a:endParaRPr lang="en-US" sz="1100" dirty="0"/>
+          </a:p>
+        </p:txBody>
+      </p:sp>
+      <p:sp>
+        <p:nvSpPr>
+          <p:cNvPr id="22" name="Text 19"/>
+          <p:cNvSpPr txBox="1"/>
+          <p:nvPr/>
+        </p:nvSpPr>
+        <p:spPr>
+          <a:xfrm>
+            <a:off x="4754880" y="2350008"/>
+            <a:ext cx="3657600" cy="1005840"/>
+          </a:xfrm>
+          <a:prstGeom prst="rect">
+            <a:avLst/>
+          </a:prstGeom>
+          <a:noFill/>
+          <a:ln/>
+        </p:spPr>
+        <p:txBody>
+          <a:bodyPr wrap="square" lIns="0" tIns="0" rIns="0" bIns="0" rtlCol="0" anchor="t"/>
+          <a:lstStyle/>
+          <a:p>
+            <a:pPr indent="0" marL="0">
+              <a:buNone/>
+            </a:pPr>
+            <a:r>
+              <a:rPr lang="en-US" sz="1500" dirty="0">
+                <a:solidFill>
+                  <a:srgbClr val="000000"/>
+                </a:solidFill>
+                <a:latin typeface="Arial" pitchFamily="34" charset="0"/>
+                <a:ea typeface="Arial" pitchFamily="34" charset="-122"/>
+                <a:cs typeface="Arial" pitchFamily="34" charset="-120"/>
+              </a:rPr>
+              <a:t>How do people actually start using it?</a:t>
+            </a:r>
+            <a:endParaRPr lang="en-US" sz="1500" dirty="0"/>
+          </a:p>
+        </p:txBody>
+      </p:sp>
+      <p:sp>
+        <p:nvSpPr>
+          <p:cNvPr id="23" name="Text 20"/>
+          <p:cNvSpPr txBox="1"/>
+          <p:nvPr/>
+        </p:nvSpPr>
+        <p:spPr>
+          <a:xfrm>
+            <a:off x="4754880" y="3429000"/>
+            <a:ext cx="3657600" cy="256032"/>
+          </a:xfrm>
+          <a:prstGeom prst="rect">
+            <a:avLst/>
+          </a:prstGeom>
+          <a:noFill/>
+          <a:ln/>
+        </p:spPr>
+        <p:txBody>
+          <a:bodyPr wrap="square" lIns="0" tIns="0" rIns="0" bIns="0" rtlCol="0" anchor="ctr"/>
+          <a:lstStyle/>
+          <a:p>
+            <a:pPr indent="0" marL="0">
+              <a:buNone/>
+            </a:pPr>
+            <a:r>
+              <a:rPr lang="en-US" sz="1100" b="1" spc="200" kern="0" dirty="0">
+                <a:solidFill>
+                  <a:srgbClr val="8C8C8C"/>
+                </a:solidFill>
+                <a:latin typeface="Arial" pitchFamily="34" charset="0"/>
+                <a:ea typeface="Arial" pitchFamily="34" charset="-122"/>
+                <a:cs typeface="Arial" pitchFamily="34" charset="-120"/>
+              </a:rPr>
+              <a:t>IN RAMER WE</a:t>
+            </a:r>
+            <a:endParaRPr lang="en-US" sz="1100" dirty="0"/>
+          </a:p>
+        </p:txBody>
+      </p:sp>
+      <p:sp>
+        <p:nvSpPr>
+          <p:cNvPr id="24" name="Text 21"/>
+          <p:cNvSpPr txBox="1"/>
+          <p:nvPr/>
+        </p:nvSpPr>
+        <p:spPr>
+          <a:xfrm>
+            <a:off x="4754880" y="3721608"/>
+            <a:ext cx="3657600" cy="1005840"/>
+          </a:xfrm>
+          <a:prstGeom prst="rect">
+            <a:avLst/>
+          </a:prstGeom>
+          <a:noFill/>
+          <a:ln/>
+        </p:spPr>
+        <p:txBody>
+          <a:bodyPr wrap="square" lIns="0" tIns="0" rIns="0" bIns="0" rtlCol="0" anchor="t"/>
+          <a:lstStyle/>
+          <a:p>
+            <a:pPr indent="0" marL="0">
+              <a:buNone/>
+            </a:pPr>
+            <a:r>
+              <a:rPr lang="en-US" sz="1500" dirty="0">
+                <a:solidFill>
+                  <a:srgbClr val="000000"/>
+                </a:solidFill>
+                <a:latin typeface="Arial" pitchFamily="34" charset="0"/>
+                <a:ea typeface="Arial" pitchFamily="34" charset="-122"/>
+                <a:cs typeface="Arial" pitchFamily="34" charset="-120"/>
+              </a:rPr>
+              <a:t>made setup two commands, with no changes to existing agent tools, and planned the rollout around real users.</a:t>
+            </a:r>
+            <a:endParaRPr lang="en-US" sz="1500" dirty="0"/>
+          </a:p>
+        </p:txBody>
+      </p:sp>
+    </p:spTree>
+  </p:cSld>
+  <p:clrMapOvr>
+    <a:masterClrMapping/>
+  </p:clrMapOvr>
+</p:sld>
+</file>
+
+<file path=ppt/slides/slide22.xml><?xml version="1.0" encoding="utf-8"?>
+<p:sld xmlns:a="http://schemas.openxmlformats.org/drawingml/2006/main" xmlns:r="http://schemas.openxmlformats.org/officeDocument/2006/relationships" xmlns:p="http://schemas.openxmlformats.org/presentationml/2006/main">
+  <p:cSld name="Slide 22">
+    <p:bg>
+      <p:bgPr>
+        <a:solidFill>
           <a:srgbClr val="FFFFFF"/>
         </a:solidFill>
       </p:bgPr>
@@ -12490,7 +13867,7 @@
                 <a:ea typeface="Arial" pitchFamily="34" charset="-122"/>
                 <a:cs typeface="Arial" pitchFamily="34" charset="-120"/>
               </a:rPr>
-              <a:t>Back to the start: iterate</a:t>
+              <a:t>Using Ramer takes three steps</a:t>
             </a:r>
             <a:endParaRPr lang="en-US" sz="3000" dirty="0"/>
           </a:p>
@@ -12529,7 +13906,7 @@
                 <a:ea typeface="Arial" pitchFamily="34" charset="-122"/>
                 <a:cs typeface="Arial" pitchFamily="34" charset="-120"/>
               </a:rPr>
-              <a:t>THE LOOP</a:t>
+              <a:t>06 IMPLEMENT</a:t>
             </a:r>
             <a:endParaRPr lang="en-US" sz="1100" dirty="0"/>
           </a:p>
@@ -12607,7 +13984,7 @@
                 <a:ea typeface="Arial" pitchFamily="34" charset="-122"/>
                 <a:cs typeface="Arial" pitchFamily="34" charset="-120"/>
               </a:rPr>
-              <a:t>21</a:t>
+              <a:t>22</a:t>
             </a:r>
             <a:endParaRPr lang="en-US" sz="1000" dirty="0"/>
           </a:p>
@@ -12615,13 +13992,1255 @@
       </p:sp>
       <p:sp>
         <p:nvSpPr>
+          <p:cNvPr id="7" name="Shape 4"/>
+          <p:cNvSpPr/>
+          <p:nvPr/>
+        </p:nvSpPr>
+        <p:spPr>
+          <a:xfrm>
+            <a:off x="457200" y="1188720"/>
+            <a:ext cx="2606040" cy="2468880"/>
+          </a:xfrm>
+          <a:prstGeom prst="rect">
+            <a:avLst/>
+          </a:prstGeom>
+          <a:solidFill>
+            <a:srgbClr val="FFFFFF"/>
+          </a:solidFill>
+          <a:ln w="19050">
+            <a:solidFill>
+              <a:srgbClr val="000000"/>
+            </a:solidFill>
+            <a:prstDash val="solid"/>
+          </a:ln>
+        </p:spPr>
+      </p:sp>
+      <p:sp>
+        <p:nvSpPr>
+          <p:cNvPr id="8" name="Text 5"/>
+          <p:cNvSpPr txBox="1"/>
+          <p:nvPr/>
+        </p:nvSpPr>
+        <p:spPr>
+          <a:xfrm>
+            <a:off x="685800" y="1325880"/>
+            <a:ext cx="914400" cy="731520"/>
+          </a:xfrm>
+          <a:prstGeom prst="rect">
+            <a:avLst/>
+          </a:prstGeom>
+          <a:noFill/>
+          <a:ln/>
+        </p:spPr>
+        <p:txBody>
+          <a:bodyPr wrap="square" lIns="0" tIns="0" rIns="0" bIns="0" rtlCol="0" anchor="ctr"/>
+          <a:lstStyle/>
+          <a:p>
+            <a:pPr indent="0" marL="0">
+              <a:buNone/>
+            </a:pPr>
+            <a:r>
+              <a:rPr lang="en-US" sz="4400" b="1" dirty="0">
+                <a:solidFill>
+                  <a:srgbClr val="000000"/>
+                </a:solidFill>
+                <a:latin typeface="Arial" pitchFamily="34" charset="0"/>
+                <a:ea typeface="Arial" pitchFamily="34" charset="-122"/>
+                <a:cs typeface="Arial" pitchFamily="34" charset="-120"/>
+              </a:rPr>
+              <a:t>1</a:t>
+            </a:r>
+            <a:endParaRPr lang="en-US" sz="4400" dirty="0"/>
+          </a:p>
+        </p:txBody>
+      </p:sp>
+      <p:sp>
+        <p:nvSpPr>
+          <p:cNvPr id="9" name="Text 6"/>
+          <p:cNvSpPr txBox="1"/>
+          <p:nvPr/>
+        </p:nvSpPr>
+        <p:spPr>
+          <a:xfrm>
+            <a:off x="685800" y="2194560"/>
+            <a:ext cx="2194560" cy="365760"/>
+          </a:xfrm>
+          <a:prstGeom prst="rect">
+            <a:avLst/>
+          </a:prstGeom>
+          <a:noFill/>
+          <a:ln/>
+        </p:spPr>
+        <p:txBody>
+          <a:bodyPr wrap="square" lIns="0" tIns="0" rIns="0" bIns="0" rtlCol="0" anchor="ctr"/>
+          <a:lstStyle/>
+          <a:p>
+            <a:pPr indent="0" marL="0">
+              <a:buNone/>
+            </a:pPr>
+            <a:r>
+              <a:rPr lang="en-US" sz="1700" b="1" dirty="0">
+                <a:solidFill>
+                  <a:srgbClr val="000000"/>
+                </a:solidFill>
+                <a:latin typeface="Arial" pitchFamily="34" charset="0"/>
+                <a:ea typeface="Arial" pitchFamily="34" charset="-122"/>
+                <a:cs typeface="Arial" pitchFamily="34" charset="-120"/>
+              </a:rPr>
+              <a:t>Install</a:t>
+            </a:r>
+            <a:endParaRPr lang="en-US" sz="1700" dirty="0"/>
+          </a:p>
+        </p:txBody>
+      </p:sp>
+      <p:sp>
+        <p:nvSpPr>
+          <p:cNvPr id="10" name="Text 7"/>
+          <p:cNvSpPr txBox="1"/>
+          <p:nvPr/>
+        </p:nvSpPr>
+        <p:spPr>
+          <a:xfrm>
+            <a:off x="685800" y="2651760"/>
+            <a:ext cx="2194560" cy="822960"/>
+          </a:xfrm>
+          <a:prstGeom prst="rect">
+            <a:avLst/>
+          </a:prstGeom>
+          <a:noFill/>
+          <a:ln/>
+        </p:spPr>
+        <p:txBody>
+          <a:bodyPr wrap="square" lIns="0" tIns="0" rIns="0" bIns="0" rtlCol="0" anchor="t"/>
+          <a:lstStyle/>
+          <a:p>
+            <a:pPr indent="0" marL="0">
+              <a:buNone/>
+            </a:pPr>
+            <a:r>
+              <a:rPr lang="en-US" sz="1200" dirty="0">
+                <a:solidFill>
+                  <a:srgbClr val="262626"/>
+                </a:solidFill>
+                <a:latin typeface="Courier New" pitchFamily="34" charset="0"/>
+                <a:ea typeface="Courier New" pitchFamily="34" charset="-122"/>
+                <a:cs typeface="Courier New" pitchFamily="34" charset="-120"/>
+              </a:rPr>
+              <a:t>pip install -r app/requirements.txt</a:t>
+            </a:r>
+            <a:endParaRPr lang="en-US" sz="1200" dirty="0"/>
+          </a:p>
+        </p:txBody>
+      </p:sp>
+      <p:sp>
+        <p:nvSpPr>
+          <p:cNvPr id="11" name="Shape 8"/>
+          <p:cNvSpPr/>
+          <p:nvPr/>
+        </p:nvSpPr>
+        <p:spPr>
+          <a:xfrm>
+            <a:off x="3246120" y="1188720"/>
+            <a:ext cx="2606040" cy="2468880"/>
+          </a:xfrm>
+          <a:prstGeom prst="rect">
+            <a:avLst/>
+          </a:prstGeom>
+          <a:solidFill>
+            <a:srgbClr val="000000"/>
+          </a:solidFill>
+          <a:ln w="19050">
+            <a:solidFill>
+              <a:srgbClr val="000000"/>
+            </a:solidFill>
+            <a:prstDash val="solid"/>
+          </a:ln>
+        </p:spPr>
+      </p:sp>
+      <p:sp>
+        <p:nvSpPr>
+          <p:cNvPr id="12" name="Text 9"/>
+          <p:cNvSpPr txBox="1"/>
+          <p:nvPr/>
+        </p:nvSpPr>
+        <p:spPr>
+          <a:xfrm>
+            <a:off x="3474720" y="1325880"/>
+            <a:ext cx="914400" cy="731520"/>
+          </a:xfrm>
+          <a:prstGeom prst="rect">
+            <a:avLst/>
+          </a:prstGeom>
+          <a:noFill/>
+          <a:ln/>
+        </p:spPr>
+        <p:txBody>
+          <a:bodyPr wrap="square" lIns="0" tIns="0" rIns="0" bIns="0" rtlCol="0" anchor="ctr"/>
+          <a:lstStyle/>
+          <a:p>
+            <a:pPr indent="0" marL="0">
+              <a:buNone/>
+            </a:pPr>
+            <a:r>
+              <a:rPr lang="en-US" sz="4400" b="1" dirty="0">
+                <a:solidFill>
+                  <a:srgbClr val="FFFFFF"/>
+                </a:solidFill>
+                <a:latin typeface="Arial" pitchFamily="34" charset="0"/>
+                <a:ea typeface="Arial" pitchFamily="34" charset="-122"/>
+                <a:cs typeface="Arial" pitchFamily="34" charset="-120"/>
+              </a:rPr>
+              <a:t>2</a:t>
+            </a:r>
+            <a:endParaRPr lang="en-US" sz="4400" dirty="0"/>
+          </a:p>
+        </p:txBody>
+      </p:sp>
+      <p:sp>
+        <p:nvSpPr>
+          <p:cNvPr id="13" name="Text 10"/>
+          <p:cNvSpPr txBox="1"/>
+          <p:nvPr/>
+        </p:nvSpPr>
+        <p:spPr>
+          <a:xfrm>
+            <a:off x="3474720" y="2194560"/>
+            <a:ext cx="2194560" cy="365760"/>
+          </a:xfrm>
+          <a:prstGeom prst="rect">
+            <a:avLst/>
+          </a:prstGeom>
+          <a:noFill/>
+          <a:ln/>
+        </p:spPr>
+        <p:txBody>
+          <a:bodyPr wrap="square" lIns="0" tIns="0" rIns="0" bIns="0" rtlCol="0" anchor="ctr"/>
+          <a:lstStyle/>
+          <a:p>
+            <a:pPr indent="0" marL="0">
+              <a:buNone/>
+            </a:pPr>
+            <a:r>
+              <a:rPr lang="en-US" sz="1700" b="1" dirty="0">
+                <a:solidFill>
+                  <a:srgbClr val="FFFFFF"/>
+                </a:solidFill>
+                <a:latin typeface="Arial" pitchFamily="34" charset="0"/>
+                <a:ea typeface="Arial" pitchFamily="34" charset="-122"/>
+                <a:cs typeface="Arial" pitchFamily="34" charset="-120"/>
+              </a:rPr>
+              <a:t>Start the proxy</a:t>
+            </a:r>
+            <a:endParaRPr lang="en-US" sz="1700" dirty="0"/>
+          </a:p>
+        </p:txBody>
+      </p:sp>
+      <p:sp>
+        <p:nvSpPr>
+          <p:cNvPr id="14" name="Text 11"/>
+          <p:cNvSpPr txBox="1"/>
+          <p:nvPr/>
+        </p:nvSpPr>
+        <p:spPr>
+          <a:xfrm>
+            <a:off x="3474720" y="2651760"/>
+            <a:ext cx="2194560" cy="822960"/>
+          </a:xfrm>
+          <a:prstGeom prst="rect">
+            <a:avLst/>
+          </a:prstGeom>
+          <a:noFill/>
+          <a:ln/>
+        </p:spPr>
+        <p:txBody>
+          <a:bodyPr wrap="square" lIns="0" tIns="0" rIns="0" bIns="0" rtlCol="0" anchor="t"/>
+          <a:lstStyle/>
+          <a:p>
+            <a:pPr indent="0" marL="0">
+              <a:buNone/>
+            </a:pPr>
+            <a:r>
+              <a:rPr lang="en-US" sz="1200" dirty="0">
+                <a:solidFill>
+                  <a:srgbClr val="BFBFBF"/>
+                </a:solidFill>
+                <a:latin typeface="Courier New" pitchFamily="34" charset="0"/>
+                <a:ea typeface="Courier New" pitchFamily="34" charset="-122"/>
+                <a:cs typeface="Courier New" pitchFamily="34" charset="-120"/>
+              </a:rPr>
+              <a:t>python -m app.cli serve --port 11435</a:t>
+            </a:r>
+            <a:endParaRPr lang="en-US" sz="1200" dirty="0"/>
+          </a:p>
+        </p:txBody>
+      </p:sp>
+      <p:sp>
+        <p:nvSpPr>
+          <p:cNvPr id="15" name="Shape 12"/>
+          <p:cNvSpPr/>
+          <p:nvPr/>
+        </p:nvSpPr>
+        <p:spPr>
+          <a:xfrm>
+            <a:off x="6035040" y="1188720"/>
+            <a:ext cx="2606040" cy="2468880"/>
+          </a:xfrm>
+          <a:prstGeom prst="rect">
+            <a:avLst/>
+          </a:prstGeom>
+          <a:solidFill>
+            <a:srgbClr val="FFFFFF"/>
+          </a:solidFill>
+          <a:ln w="19050">
+            <a:solidFill>
+              <a:srgbClr val="000000"/>
+            </a:solidFill>
+            <a:prstDash val="solid"/>
+          </a:ln>
+        </p:spPr>
+      </p:sp>
+      <p:sp>
+        <p:nvSpPr>
+          <p:cNvPr id="16" name="Text 13"/>
+          <p:cNvSpPr txBox="1"/>
+          <p:nvPr/>
+        </p:nvSpPr>
+        <p:spPr>
+          <a:xfrm>
+            <a:off x="6263640" y="1325880"/>
+            <a:ext cx="914400" cy="731520"/>
+          </a:xfrm>
+          <a:prstGeom prst="rect">
+            <a:avLst/>
+          </a:prstGeom>
+          <a:noFill/>
+          <a:ln/>
+        </p:spPr>
+        <p:txBody>
+          <a:bodyPr wrap="square" lIns="0" tIns="0" rIns="0" bIns="0" rtlCol="0" anchor="ctr"/>
+          <a:lstStyle/>
+          <a:p>
+            <a:pPr indent="0" marL="0">
+              <a:buNone/>
+            </a:pPr>
+            <a:r>
+              <a:rPr lang="en-US" sz="4400" b="1" dirty="0">
+                <a:solidFill>
+                  <a:srgbClr val="000000"/>
+                </a:solidFill>
+                <a:latin typeface="Arial" pitchFamily="34" charset="0"/>
+                <a:ea typeface="Arial" pitchFamily="34" charset="-122"/>
+                <a:cs typeface="Arial" pitchFamily="34" charset="-120"/>
+              </a:rPr>
+              <a:t>3</a:t>
+            </a:r>
+            <a:endParaRPr lang="en-US" sz="4400" dirty="0"/>
+          </a:p>
+        </p:txBody>
+      </p:sp>
+      <p:sp>
+        <p:nvSpPr>
+          <p:cNvPr id="17" name="Text 14"/>
+          <p:cNvSpPr txBox="1"/>
+          <p:nvPr/>
+        </p:nvSpPr>
+        <p:spPr>
+          <a:xfrm>
+            <a:off x="6263640" y="2194560"/>
+            <a:ext cx="2194560" cy="365760"/>
+          </a:xfrm>
+          <a:prstGeom prst="rect">
+            <a:avLst/>
+          </a:prstGeom>
+          <a:noFill/>
+          <a:ln/>
+        </p:spPr>
+        <p:txBody>
+          <a:bodyPr wrap="square" lIns="0" tIns="0" rIns="0" bIns="0" rtlCol="0" anchor="ctr"/>
+          <a:lstStyle/>
+          <a:p>
+            <a:pPr indent="0" marL="0">
+              <a:buNone/>
+            </a:pPr>
+            <a:r>
+              <a:rPr lang="en-US" sz="1700" b="1" dirty="0">
+                <a:solidFill>
+                  <a:srgbClr val="000000"/>
+                </a:solidFill>
+                <a:latin typeface="Arial" pitchFamily="34" charset="0"/>
+                <a:ea typeface="Arial" pitchFamily="34" charset="-122"/>
+                <a:cs typeface="Arial" pitchFamily="34" charset="-120"/>
+              </a:rPr>
+              <a:t>Repoint your agent</a:t>
+            </a:r>
+            <a:endParaRPr lang="en-US" sz="1700" dirty="0"/>
+          </a:p>
+        </p:txBody>
+      </p:sp>
+      <p:sp>
+        <p:nvSpPr>
+          <p:cNvPr id="18" name="Text 15"/>
+          <p:cNvSpPr txBox="1"/>
+          <p:nvPr/>
+        </p:nvSpPr>
+        <p:spPr>
+          <a:xfrm>
+            <a:off x="6263640" y="2651760"/>
+            <a:ext cx="2194560" cy="822960"/>
+          </a:xfrm>
+          <a:prstGeom prst="rect">
+            <a:avLst/>
+          </a:prstGeom>
+          <a:noFill/>
+          <a:ln/>
+        </p:spPr>
+        <p:txBody>
+          <a:bodyPr wrap="square" lIns="0" tIns="0" rIns="0" bIns="0" rtlCol="0" anchor="t"/>
+          <a:lstStyle/>
+          <a:p>
+            <a:pPr indent="0" marL="0">
+              <a:buNone/>
+            </a:pPr>
+            <a:r>
+              <a:rPr lang="en-US" sz="1200" dirty="0">
+                <a:solidFill>
+                  <a:srgbClr val="262626"/>
+                </a:solidFill>
+                <a:latin typeface="Courier New" pitchFamily="34" charset="0"/>
+                <a:ea typeface="Courier New" pitchFamily="34" charset="-122"/>
+                <a:cs typeface="Courier New" pitchFamily="34" charset="-120"/>
+              </a:rPr>
+              <a:t>http://127.0.0.1:11435 instead of Ollama's 11434</a:t>
+            </a:r>
+            <a:endParaRPr lang="en-US" sz="1200" dirty="0"/>
+          </a:p>
+        </p:txBody>
+      </p:sp>
+      <p:sp>
+        <p:nvSpPr>
+          <p:cNvPr id="19" name="Shape 16"/>
+          <p:cNvSpPr/>
+          <p:nvPr/>
+        </p:nvSpPr>
+        <p:spPr>
+          <a:xfrm>
+            <a:off x="457200" y="3840480"/>
+            <a:ext cx="8229600" cy="731520"/>
+          </a:xfrm>
+          <a:prstGeom prst="rect">
+            <a:avLst/>
+          </a:prstGeom>
+          <a:solidFill>
+            <a:srgbClr val="F2F2F2"/>
+          </a:solidFill>
+          <a:ln w="12700">
+            <a:solidFill>
+              <a:srgbClr val="F2F2F2"/>
+            </a:solidFill>
+            <a:prstDash val="solid"/>
+          </a:ln>
+        </p:spPr>
+      </p:sp>
+      <p:sp>
+        <p:nvSpPr>
+          <p:cNvPr id="20" name="Text 17"/>
+          <p:cNvSpPr txBox="1"/>
+          <p:nvPr/>
+        </p:nvSpPr>
+        <p:spPr>
+          <a:xfrm>
+            <a:off x="731520" y="3840480"/>
+            <a:ext cx="7680960" cy="731520"/>
+          </a:xfrm>
+          <a:prstGeom prst="rect">
+            <a:avLst/>
+          </a:prstGeom>
+          <a:noFill/>
+          <a:ln/>
+        </p:spPr>
+        <p:txBody>
+          <a:bodyPr wrap="square" lIns="0" tIns="0" rIns="0" bIns="0" rtlCol="0" anchor="ctr"/>
+          <a:lstStyle/>
+          <a:p>
+            <a:pPr indent="0" marL="0">
+              <a:buNone/>
+            </a:pPr>
+            <a:r>
+              <a:rPr lang="en-US" sz="1400" b="1" dirty="0">
+                <a:solidFill>
+                  <a:srgbClr val="000000"/>
+                </a:solidFill>
+                <a:latin typeface="Arial" pitchFamily="34" charset="0"/>
+                <a:ea typeface="Arial" pitchFamily="34" charset="-122"/>
+                <a:cs typeface="Arial" pitchFamily="34" charset="-120"/>
+              </a:rPr>
+              <a:t>Needs: </a:t>
+            </a:r>
+            <a:pPr indent="0" marL="0">
+              <a:buNone/>
+            </a:pPr>
+            <a:r>
+              <a:rPr lang="en-US" sz="1400" dirty="0">
+                <a:solidFill>
+                  <a:srgbClr val="000000"/>
+                </a:solidFill>
+                <a:latin typeface="Arial" pitchFamily="34" charset="0"/>
+                <a:ea typeface="Arial" pitchFamily="34" charset="-122"/>
+                <a:cs typeface="Arial" pitchFamily="34" charset="-120"/>
+              </a:rPr>
+              <a:t>Python 3.10+, Ollama, and a discrete NVIDIA GPU. Tested on Windows with aider and the pi CLI.</a:t>
+            </a:r>
+            <a:endParaRPr lang="en-US" sz="1400" dirty="0"/>
+          </a:p>
+        </p:txBody>
+      </p:sp>
+    </p:spTree>
+  </p:cSld>
+  <p:clrMapOvr>
+    <a:masterClrMapping/>
+  </p:clrMapOvr>
+</p:sld>
+</file>
+
+<file path=ppt/slides/slide23.xml><?xml version="1.0" encoding="utf-8"?>
+<p:sld xmlns:a="http://schemas.openxmlformats.org/drawingml/2006/main" xmlns:r="http://schemas.openxmlformats.org/officeDocument/2006/relationships" xmlns:p="http://schemas.openxmlformats.org/presentationml/2006/main">
+  <p:cSld name="Slide 23">
+    <p:bg>
+      <p:bgPr>
+        <a:solidFill>
+          <a:srgbClr val="FFFFFF"/>
+        </a:solidFill>
+      </p:bgPr>
+    </p:bg>
+    <p:spTree>
+      <p:nvGrpSpPr>
+        <p:cNvPr id="1" name=""/>
+        <p:cNvGrpSpPr/>
+        <p:nvPr/>
+      </p:nvGrpSpPr>
+      <p:grpSpPr>
+        <a:xfrm>
+          <a:off x="0" y="0"/>
+          <a:ext cx="0" cy="0"/>
+          <a:chOff x="0" y="0"/>
+          <a:chExt cx="0" cy="0"/>
+        </a:xfrm>
+      </p:grpSpPr>
+      <p:sp>
+        <p:nvSpPr>
+          <p:cNvPr id="2" name="Text 0"/>
+          <p:cNvSpPr txBox="1"/>
+          <p:nvPr/>
+        </p:nvSpPr>
+        <p:spPr>
+          <a:xfrm>
+            <a:off x="457200" y="320040"/>
+            <a:ext cx="6675120" cy="640080"/>
+          </a:xfrm>
+          <a:prstGeom prst="rect">
+            <a:avLst/>
+          </a:prstGeom>
+          <a:noFill/>
+          <a:ln/>
+        </p:spPr>
+        <p:txBody>
+          <a:bodyPr wrap="square" lIns="0" tIns="0" rIns="0" bIns="0" rtlCol="0" anchor="ctr"/>
+          <a:lstStyle/>
+          <a:p>
+            <a:pPr indent="0" marL="0">
+              <a:buNone/>
+            </a:pPr>
+            <a:r>
+              <a:rPr lang="en-US" sz="3000" b="1" dirty="0">
+                <a:solidFill>
+                  <a:srgbClr val="000000"/>
+                </a:solidFill>
+                <a:latin typeface="Arial" pitchFamily="34" charset="0"/>
+                <a:ea typeface="Arial" pitchFamily="34" charset="-122"/>
+                <a:cs typeface="Arial" pitchFamily="34" charset="-120"/>
+              </a:rPr>
+              <a:t>Where implementation stands</a:t>
+            </a:r>
+            <a:endParaRPr lang="en-US" sz="3000" dirty="0"/>
+          </a:p>
+        </p:txBody>
+      </p:sp>
+      <p:sp>
+        <p:nvSpPr>
+          <p:cNvPr id="3" name="Text 1"/>
+          <p:cNvSpPr txBox="1"/>
+          <p:nvPr/>
+        </p:nvSpPr>
+        <p:spPr>
+          <a:xfrm>
+            <a:off x="7132320" y="411480"/>
+            <a:ext cx="1554480" cy="457200"/>
+          </a:xfrm>
+          <a:prstGeom prst="rect">
+            <a:avLst/>
+          </a:prstGeom>
+          <a:noFill/>
+          <a:ln/>
+        </p:spPr>
+        <p:txBody>
+          <a:bodyPr wrap="square" lIns="0" tIns="0" rIns="0" bIns="0" rtlCol="0" anchor="ctr"/>
+          <a:lstStyle/>
+          <a:p>
+            <a:pPr algn="r" indent="0" marL="0">
+              <a:buNone/>
+            </a:pPr>
+            <a:r>
+              <a:rPr lang="en-US" sz="1100" b="1" dirty="0">
+                <a:solidFill>
+                  <a:srgbClr val="8C8C8C"/>
+                </a:solidFill>
+                <a:latin typeface="Arial" pitchFamily="34" charset="0"/>
+                <a:ea typeface="Arial" pitchFamily="34" charset="-122"/>
+                <a:cs typeface="Arial" pitchFamily="34" charset="-120"/>
+              </a:rPr>
+              <a:t>06 IMPLEMENT</a:t>
+            </a:r>
+            <a:endParaRPr lang="en-US" sz="1100" dirty="0"/>
+          </a:p>
+        </p:txBody>
+      </p:sp>
+      <p:sp>
+        <p:nvSpPr>
+          <p:cNvPr id="4" name="Text 2"/>
+          <p:cNvSpPr txBox="1"/>
+          <p:nvPr/>
+        </p:nvSpPr>
+        <p:spPr>
+          <a:xfrm>
+            <a:off x="457200" y="4754880"/>
+            <a:ext cx="4572000" cy="228600"/>
+          </a:xfrm>
+          <a:prstGeom prst="rect">
+            <a:avLst/>
+          </a:prstGeom>
+          <a:noFill/>
+          <a:ln/>
+        </p:spPr>
+        <p:txBody>
+          <a:bodyPr wrap="square" lIns="0" tIns="0" rIns="0" bIns="0" rtlCol="0" anchor="ctr"/>
+          <a:lstStyle/>
+          <a:p>
+            <a:pPr indent="0" marL="0">
+              <a:buNone/>
+            </a:pPr>
+            <a:r>
+              <a:rPr lang="en-US" sz="900" spc="200" kern="0" dirty="0">
+                <a:solidFill>
+                  <a:srgbClr val="8C8C8C"/>
+                </a:solidFill>
+                <a:latin typeface="Arial" pitchFamily="34" charset="0"/>
+                <a:ea typeface="Arial" pitchFamily="34" charset="-122"/>
+                <a:cs typeface="Arial" pitchFamily="34" charset="-120"/>
+              </a:rPr>
+              <a:t>RAMER  ·  A DESIGN THINKING STORY</a:t>
+            </a:r>
+            <a:endParaRPr lang="en-US" sz="900" dirty="0"/>
+          </a:p>
+        </p:txBody>
+      </p:sp>
+      <p:sp>
+        <p:nvSpPr>
+          <p:cNvPr id="5" name="Text 3"/>
+          <p:cNvSpPr txBox="1"/>
+          <p:nvPr/>
+        </p:nvSpPr>
+        <p:spPr>
+          <a:xfrm>
+            <a:off x="8229600" y="4754880"/>
+            <a:ext cx="457200" cy="228600"/>
+          </a:xfrm>
+          <a:prstGeom prst="rect">
+            <a:avLst/>
+          </a:prstGeom>
+          <a:noFill/>
+          <a:ln/>
+        </p:spPr>
+        <p:txBody>
+          <a:bodyPr wrap="square" lIns="0" tIns="0" rIns="0" bIns="0" rtlCol="0" anchor="ctr"/>
+          <a:lstStyle/>
+          <a:p>
+            <a:pPr algn="r" indent="0" marL="0">
+              <a:buNone/>
+            </a:pPr>
+            <a:r>
+              <a:rPr lang="en-US" sz="1000" dirty="0">
+                <a:solidFill>
+                  <a:srgbClr val="8C8C8C"/>
+                </a:solidFill>
+                <a:latin typeface="Arial" pitchFamily="34" charset="0"/>
+                <a:ea typeface="Arial" pitchFamily="34" charset="-122"/>
+                <a:cs typeface="Arial" pitchFamily="34" charset="-120"/>
+              </a:rPr>
+              <a:t>23</a:t>
+            </a:r>
+            <a:endParaRPr lang="en-US" sz="1000" dirty="0"/>
+          </a:p>
+        </p:txBody>
+      </p:sp>
+      <p:sp>
+        <p:nvSpPr>
+          <p:cNvPr id="7" name="Shape 4"/>
+          <p:cNvSpPr/>
+          <p:nvPr/>
+        </p:nvSpPr>
+        <p:spPr>
+          <a:xfrm>
+            <a:off x="457200" y="1188720"/>
+            <a:ext cx="4023360" cy="2788920"/>
+          </a:xfrm>
+          <a:prstGeom prst="rect">
+            <a:avLst/>
+          </a:prstGeom>
+          <a:solidFill>
+            <a:srgbClr val="000000"/>
+          </a:solidFill>
+          <a:ln w="19050">
+            <a:solidFill>
+              <a:srgbClr val="000000"/>
+            </a:solidFill>
+            <a:prstDash val="solid"/>
+          </a:ln>
+        </p:spPr>
+      </p:sp>
+      <p:sp>
+        <p:nvSpPr>
+          <p:cNvPr id="8" name="Text 5"/>
+          <p:cNvSpPr txBox="1"/>
+          <p:nvPr/>
+        </p:nvSpPr>
+        <p:spPr>
+          <a:xfrm>
+            <a:off x="731520" y="1417320"/>
+            <a:ext cx="2834640" cy="548640"/>
+          </a:xfrm>
+          <a:prstGeom prst="rect">
+            <a:avLst/>
+          </a:prstGeom>
+          <a:noFill/>
+          <a:ln/>
+        </p:spPr>
+        <p:txBody>
+          <a:bodyPr wrap="square" lIns="0" tIns="0" rIns="0" bIns="0" rtlCol="0" anchor="ctr"/>
+          <a:lstStyle/>
+          <a:p>
+            <a:pPr indent="0" marL="0">
+              <a:buNone/>
+            </a:pPr>
+            <a:r>
+              <a:rPr lang="en-US" sz="2000" b="1" dirty="0">
+                <a:solidFill>
+                  <a:srgbClr val="FFFFFF"/>
+                </a:solidFill>
+                <a:latin typeface="Arial" pitchFamily="34" charset="0"/>
+                <a:ea typeface="Arial" pitchFamily="34" charset="-122"/>
+                <a:cs typeface="Arial" pitchFamily="34" charset="-120"/>
+              </a:rPr>
+              <a:t>Done</a:t>
+            </a:r>
+            <a:endParaRPr lang="en-US" sz="2000" dirty="0"/>
+          </a:p>
+        </p:txBody>
+      </p:sp>
+      <p:sp>
+        <p:nvSpPr>
+          <p:cNvPr id="9" name="Text 6"/>
+          <p:cNvSpPr txBox="1"/>
+          <p:nvPr/>
+        </p:nvSpPr>
+        <p:spPr>
+          <a:xfrm>
+            <a:off x="731520" y="2194560"/>
+            <a:ext cx="3520440" cy="1645920"/>
+          </a:xfrm>
+          <a:prstGeom prst="rect">
+            <a:avLst/>
+          </a:prstGeom>
+          <a:noFill/>
+          <a:ln/>
+        </p:spPr>
+        <p:txBody>
+          <a:bodyPr wrap="square" lIns="0" tIns="0" rIns="0" bIns="0" rtlCol="0" anchor="t"/>
+          <a:lstStyle/>
+          <a:p>
+            <a:pPr marL="342900" indent="-342900">
+              <a:spcAft>
+                <a:spcPts val="1000"/>
+              </a:spcAft>
+              <a:buSzPct val="100000"/>
+              <a:buChar char="•"/>
+            </a:pPr>
+            <a:r>
+              <a:rPr lang="en-US" sz="1400" dirty="0">
+                <a:solidFill>
+                  <a:srgbClr val="FFFFFF"/>
+                </a:solidFill>
+                <a:latin typeface="Arial" pitchFamily="34" charset="0"/>
+                <a:ea typeface="Arial" pitchFamily="34" charset="-122"/>
+                <a:cs typeface="Arial" pitchFamily="34" charset="-120"/>
+              </a:rPr>
+              <a:t>Working proxy, command line tool and desktop app</a:t>
+            </a:r>
+            <a:endParaRPr lang="en-US" sz="1400" dirty="0"/>
+          </a:p>
+          <a:p>
+            <a:pPr marL="342900" indent="-342900">
+              <a:spcAft>
+                <a:spcPts val="1000"/>
+              </a:spcAft>
+              <a:buSzPct val="100000"/>
+              <a:buChar char="•"/>
+            </a:pPr>
+            <a:r>
+              <a:rPr lang="en-US" sz="1400" dirty="0">
+                <a:solidFill>
+                  <a:srgbClr val="FFFFFF"/>
+                </a:solidFill>
+                <a:latin typeface="Arial" pitchFamily="34" charset="0"/>
+                <a:ea typeface="Arial" pitchFamily="34" charset="-122"/>
+                <a:cs typeface="Arial" pitchFamily="34" charset="-120"/>
+              </a:rPr>
+              <a:t>Works with Ollama and OpenAI-style APIs</a:t>
+            </a:r>
+            <a:endParaRPr lang="en-US" sz="1400" dirty="0"/>
+          </a:p>
+          <a:p>
+            <a:pPr marL="342900" indent="-342900">
+              <a:spcAft>
+                <a:spcPts val="1000"/>
+              </a:spcAft>
+              <a:buSzPct val="100000"/>
+              <a:buChar char="•"/>
+            </a:pPr>
+            <a:r>
+              <a:rPr lang="en-US" sz="1400" dirty="0">
+                <a:solidFill>
+                  <a:srgbClr val="FFFFFF"/>
+                </a:solidFill>
+                <a:latin typeface="Arial" pitchFamily="34" charset="0"/>
+                <a:ea typeface="Arial" pitchFamily="34" charset="-122"/>
+                <a:cs typeface="Arial" pitchFamily="34" charset="-120"/>
+              </a:rPr>
+              <a:t>Validated on a real machine with two third-party agents</a:t>
+            </a:r>
+            <a:endParaRPr lang="en-US" sz="1400" dirty="0"/>
+          </a:p>
+        </p:txBody>
+      </p:sp>
+      <p:sp>
+        <p:nvSpPr>
+          <p:cNvPr id="10" name="Shape 7"/>
+          <p:cNvSpPr/>
+          <p:nvPr/>
+        </p:nvSpPr>
+        <p:spPr>
+          <a:xfrm>
+            <a:off x="4663440" y="1188720"/>
+            <a:ext cx="4023360" cy="2788920"/>
+          </a:xfrm>
+          <a:prstGeom prst="rect">
+            <a:avLst/>
+          </a:prstGeom>
+          <a:solidFill>
+            <a:srgbClr val="FFFFFF"/>
+          </a:solidFill>
+          <a:ln w="19050">
+            <a:solidFill>
+              <a:srgbClr val="000000"/>
+            </a:solidFill>
+            <a:prstDash val="solid"/>
+          </a:ln>
+        </p:spPr>
+      </p:sp>
+      <p:sp>
+        <p:nvSpPr>
+          <p:cNvPr id="11" name="Text 8"/>
+          <p:cNvSpPr txBox="1"/>
+          <p:nvPr/>
+        </p:nvSpPr>
+        <p:spPr>
+          <a:xfrm>
+            <a:off x="4937760" y="1417320"/>
+            <a:ext cx="2834640" cy="548640"/>
+          </a:xfrm>
+          <a:prstGeom prst="rect">
+            <a:avLst/>
+          </a:prstGeom>
+          <a:noFill/>
+          <a:ln/>
+        </p:spPr>
+        <p:txBody>
+          <a:bodyPr wrap="square" lIns="0" tIns="0" rIns="0" bIns="0" rtlCol="0" anchor="ctr"/>
+          <a:lstStyle/>
+          <a:p>
+            <a:pPr indent="0" marL="0">
+              <a:buNone/>
+            </a:pPr>
+            <a:r>
+              <a:rPr lang="en-US" sz="2000" b="1" dirty="0">
+                <a:solidFill>
+                  <a:srgbClr val="000000"/>
+                </a:solidFill>
+                <a:latin typeface="Arial" pitchFamily="34" charset="0"/>
+                <a:ea typeface="Arial" pitchFamily="34" charset="-122"/>
+                <a:cs typeface="Arial" pitchFamily="34" charset="-120"/>
+              </a:rPr>
+              <a:t>Next</a:t>
+            </a:r>
+            <a:endParaRPr lang="en-US" sz="2000" dirty="0"/>
+          </a:p>
+        </p:txBody>
+      </p:sp>
+      <p:sp>
+        <p:nvSpPr>
+          <p:cNvPr id="12" name="Text 9"/>
+          <p:cNvSpPr txBox="1"/>
+          <p:nvPr/>
+        </p:nvSpPr>
+        <p:spPr>
+          <a:xfrm>
+            <a:off x="4937760" y="2194560"/>
+            <a:ext cx="3520440" cy="1645920"/>
+          </a:xfrm>
+          <a:prstGeom prst="rect">
+            <a:avLst/>
+          </a:prstGeom>
+          <a:noFill/>
+          <a:ln/>
+        </p:spPr>
+        <p:txBody>
+          <a:bodyPr wrap="square" lIns="0" tIns="0" rIns="0" bIns="0" rtlCol="0" anchor="t"/>
+          <a:lstStyle/>
+          <a:p>
+            <a:pPr marL="342900" indent="-342900">
+              <a:spcAft>
+                <a:spcPts val="1000"/>
+              </a:spcAft>
+              <a:buSzPct val="100000"/>
+              <a:buChar char="•"/>
+            </a:pPr>
+            <a:r>
+              <a:rPr lang="en-US" sz="1400" dirty="0">
+                <a:solidFill>
+                  <a:srgbClr val="000000"/>
+                </a:solidFill>
+                <a:latin typeface="Arial" pitchFamily="34" charset="0"/>
+                <a:ea typeface="Arial" pitchFamily="34" charset="-122"/>
+                <a:cs typeface="Arial" pitchFamily="34" charset="-120"/>
+              </a:rPr>
+              <a:t>Interview real local AI users</a:t>
+            </a:r>
+            <a:endParaRPr lang="en-US" sz="1400" dirty="0"/>
+          </a:p>
+          <a:p>
+            <a:pPr marL="342900" indent="-342900">
+              <a:spcAft>
+                <a:spcPts val="1000"/>
+              </a:spcAft>
+              <a:buSzPct val="100000"/>
+              <a:buChar char="•"/>
+            </a:pPr>
+            <a:r>
+              <a:rPr lang="en-US" sz="1400" dirty="0">
+                <a:solidFill>
+                  <a:srgbClr val="000000"/>
+                </a:solidFill>
+                <a:latin typeface="Arial" pitchFamily="34" charset="0"/>
+                <a:ea typeface="Arial" pitchFamily="34" charset="-122"/>
+                <a:cs typeface="Arial" pitchFamily="34" charset="-120"/>
+              </a:rPr>
+              <a:t>Ask early testers to try it and tell us the truth</a:t>
+            </a:r>
+            <a:endParaRPr lang="en-US" sz="1400" dirty="0"/>
+          </a:p>
+          <a:p>
+            <a:pPr marL="342900" indent="-342900">
+              <a:spcAft>
+                <a:spcPts val="1000"/>
+              </a:spcAft>
+              <a:buSzPct val="100000"/>
+              <a:buChar char="•"/>
+            </a:pPr>
+            <a:r>
+              <a:rPr lang="en-US" sz="1400" dirty="0">
+                <a:solidFill>
+                  <a:srgbClr val="000000"/>
+                </a:solidFill>
+                <a:latin typeface="Arial" pitchFamily="34" charset="0"/>
+                <a:ea typeface="Arial" pitchFamily="34" charset="-122"/>
+                <a:cs typeface="Arial" pitchFamily="34" charset="-120"/>
+              </a:rPr>
+              <a:t>Learn what breaks on other machines, such as Linux</a:t>
+            </a:r>
+            <a:endParaRPr lang="en-US" sz="1400" dirty="0"/>
+          </a:p>
+        </p:txBody>
+      </p:sp>
+      <p:sp>
+        <p:nvSpPr>
+          <p:cNvPr id="13" name="Shape 10"/>
+          <p:cNvSpPr/>
+          <p:nvPr/>
+        </p:nvSpPr>
+        <p:spPr>
+          <a:xfrm>
+            <a:off x="457200" y="4114800"/>
+            <a:ext cx="8229600" cy="457200"/>
+          </a:xfrm>
+          <a:prstGeom prst="rect">
+            <a:avLst/>
+          </a:prstGeom>
+          <a:solidFill>
+            <a:srgbClr val="000000"/>
+          </a:solidFill>
+          <a:ln w="12700">
+            <a:solidFill>
+              <a:srgbClr val="000000"/>
+            </a:solidFill>
+            <a:prstDash val="solid"/>
+          </a:ln>
+        </p:spPr>
+      </p:sp>
+      <p:sp>
+        <p:nvSpPr>
+          <p:cNvPr id="14" name="Text 11"/>
+          <p:cNvSpPr txBox="1"/>
+          <p:nvPr/>
+        </p:nvSpPr>
+        <p:spPr>
+          <a:xfrm>
+            <a:off x="731520" y="4114800"/>
+            <a:ext cx="7680960" cy="457200"/>
+          </a:xfrm>
+          <a:prstGeom prst="rect">
+            <a:avLst/>
+          </a:prstGeom>
+          <a:noFill/>
+          <a:ln/>
+        </p:spPr>
+        <p:txBody>
+          <a:bodyPr wrap="square" lIns="0" tIns="0" rIns="0" bIns="0" rtlCol="0" anchor="ctr"/>
+          <a:lstStyle/>
+          <a:p>
+            <a:pPr indent="0" marL="0">
+              <a:buNone/>
+            </a:pPr>
+            <a:r>
+              <a:rPr lang="en-US" sz="1400" b="1" dirty="0">
+                <a:solidFill>
+                  <a:srgbClr val="FFFFFF"/>
+                </a:solidFill>
+                <a:latin typeface="Arial" pitchFamily="34" charset="0"/>
+                <a:ea typeface="Arial" pitchFamily="34" charset="-122"/>
+                <a:cs typeface="Arial" pitchFamily="34" charset="-120"/>
+              </a:rPr>
+              <a:t>Honest status: built and validated, but not yet in front of real users.</a:t>
+            </a:r>
+            <a:endParaRPr lang="en-US" sz="1400" dirty="0"/>
+          </a:p>
+        </p:txBody>
+      </p:sp>
+    </p:spTree>
+  </p:cSld>
+  <p:clrMapOvr>
+    <a:masterClrMapping/>
+  </p:clrMapOvr>
+</p:sld>
+</file>
+
+<file path=ppt/slides/slide24.xml><?xml version="1.0" encoding="utf-8"?>
+<p:sld xmlns:a="http://schemas.openxmlformats.org/drawingml/2006/main" xmlns:r="http://schemas.openxmlformats.org/officeDocument/2006/relationships" xmlns:p="http://schemas.openxmlformats.org/presentationml/2006/main">
+  <p:cSld name="Slide 24">
+    <p:bg>
+      <p:bgPr>
+        <a:solidFill>
+          <a:srgbClr val="FFFFFF"/>
+        </a:solidFill>
+      </p:bgPr>
+    </p:bg>
+    <p:spTree>
+      <p:nvGrpSpPr>
+        <p:cNvPr id="1" name=""/>
+        <p:cNvGrpSpPr/>
+        <p:nvPr/>
+      </p:nvGrpSpPr>
+      <p:grpSpPr>
+        <a:xfrm>
+          <a:off x="0" y="0"/>
+          <a:ext cx="0" cy="0"/>
+          <a:chOff x="0" y="0"/>
+          <a:chExt cx="0" cy="0"/>
+        </a:xfrm>
+      </p:grpSpPr>
+      <p:sp>
+        <p:nvSpPr>
+          <p:cNvPr id="2" name="Text 0"/>
+          <p:cNvSpPr txBox="1"/>
+          <p:nvPr/>
+        </p:nvSpPr>
+        <p:spPr>
+          <a:xfrm>
+            <a:off x="457200" y="320040"/>
+            <a:ext cx="6675120" cy="640080"/>
+          </a:xfrm>
+          <a:prstGeom prst="rect">
+            <a:avLst/>
+          </a:prstGeom>
+          <a:noFill/>
+          <a:ln/>
+        </p:spPr>
+        <p:txBody>
+          <a:bodyPr wrap="square" lIns="0" tIns="0" rIns="0" bIns="0" rtlCol="0" anchor="ctr"/>
+          <a:lstStyle/>
+          <a:p>
+            <a:pPr indent="0" marL="0">
+              <a:buNone/>
+            </a:pPr>
+            <a:r>
+              <a:rPr lang="en-US" sz="3000" b="1" dirty="0">
+                <a:solidFill>
+                  <a:srgbClr val="000000"/>
+                </a:solidFill>
+                <a:latin typeface="Arial" pitchFamily="34" charset="0"/>
+                <a:ea typeface="Arial" pitchFamily="34" charset="-122"/>
+                <a:cs typeface="Arial" pitchFamily="34" charset="-120"/>
+              </a:rPr>
+              <a:t>Back to the start: iterate</a:t>
+            </a:r>
+            <a:endParaRPr lang="en-US" sz="3000" dirty="0"/>
+          </a:p>
+        </p:txBody>
+      </p:sp>
+      <p:sp>
+        <p:nvSpPr>
+          <p:cNvPr id="3" name="Text 1"/>
+          <p:cNvSpPr txBox="1"/>
+          <p:nvPr/>
+        </p:nvSpPr>
+        <p:spPr>
+          <a:xfrm>
+            <a:off x="7132320" y="411480"/>
+            <a:ext cx="1554480" cy="457200"/>
+          </a:xfrm>
+          <a:prstGeom prst="rect">
+            <a:avLst/>
+          </a:prstGeom>
+          <a:noFill/>
+          <a:ln/>
+        </p:spPr>
+        <p:txBody>
+          <a:bodyPr wrap="square" lIns="0" tIns="0" rIns="0" bIns="0" rtlCol="0" anchor="ctr"/>
+          <a:lstStyle/>
+          <a:p>
+            <a:pPr algn="r" indent="0" marL="0">
+              <a:buNone/>
+            </a:pPr>
+            <a:r>
+              <a:rPr lang="en-US" sz="1100" b="1" dirty="0">
+                <a:solidFill>
+                  <a:srgbClr val="8C8C8C"/>
+                </a:solidFill>
+                <a:latin typeface="Arial" pitchFamily="34" charset="0"/>
+                <a:ea typeface="Arial" pitchFamily="34" charset="-122"/>
+                <a:cs typeface="Arial" pitchFamily="34" charset="-120"/>
+              </a:rPr>
+              <a:t>THE LOOP</a:t>
+            </a:r>
+            <a:endParaRPr lang="en-US" sz="1100" dirty="0"/>
+          </a:p>
+        </p:txBody>
+      </p:sp>
+      <p:sp>
+        <p:nvSpPr>
+          <p:cNvPr id="4" name="Text 2"/>
+          <p:cNvSpPr txBox="1"/>
+          <p:nvPr/>
+        </p:nvSpPr>
+        <p:spPr>
+          <a:xfrm>
+            <a:off x="457200" y="4754880"/>
+            <a:ext cx="4572000" cy="228600"/>
+          </a:xfrm>
+          <a:prstGeom prst="rect">
+            <a:avLst/>
+          </a:prstGeom>
+          <a:noFill/>
+          <a:ln/>
+        </p:spPr>
+        <p:txBody>
+          <a:bodyPr wrap="square" lIns="0" tIns="0" rIns="0" bIns="0" rtlCol="0" anchor="ctr"/>
+          <a:lstStyle/>
+          <a:p>
+            <a:pPr indent="0" marL="0">
+              <a:buNone/>
+            </a:pPr>
+            <a:r>
+              <a:rPr lang="en-US" sz="900" spc="200" kern="0" dirty="0">
+                <a:solidFill>
+                  <a:srgbClr val="8C8C8C"/>
+                </a:solidFill>
+                <a:latin typeface="Arial" pitchFamily="34" charset="0"/>
+                <a:ea typeface="Arial" pitchFamily="34" charset="-122"/>
+                <a:cs typeface="Arial" pitchFamily="34" charset="-120"/>
+              </a:rPr>
+              <a:t>RAMER  ·  A DESIGN THINKING STORY</a:t>
+            </a:r>
+            <a:endParaRPr lang="en-US" sz="900" dirty="0"/>
+          </a:p>
+        </p:txBody>
+      </p:sp>
+      <p:sp>
+        <p:nvSpPr>
+          <p:cNvPr id="5" name="Text 3"/>
+          <p:cNvSpPr txBox="1"/>
+          <p:nvPr/>
+        </p:nvSpPr>
+        <p:spPr>
+          <a:xfrm>
+            <a:off x="8229600" y="4754880"/>
+            <a:ext cx="457200" cy="228600"/>
+          </a:xfrm>
+          <a:prstGeom prst="rect">
+            <a:avLst/>
+          </a:prstGeom>
+          <a:noFill/>
+          <a:ln/>
+        </p:spPr>
+        <p:txBody>
+          <a:bodyPr wrap="square" lIns="0" tIns="0" rIns="0" bIns="0" rtlCol="0" anchor="ctr"/>
+          <a:lstStyle/>
+          <a:p>
+            <a:pPr algn="r" indent="0" marL="0">
+              <a:buNone/>
+            </a:pPr>
+            <a:r>
+              <a:rPr lang="en-US" sz="1000" dirty="0">
+                <a:solidFill>
+                  <a:srgbClr val="8C8C8C"/>
+                </a:solidFill>
+                <a:latin typeface="Arial" pitchFamily="34" charset="0"/>
+                <a:ea typeface="Arial" pitchFamily="34" charset="-122"/>
+                <a:cs typeface="Arial" pitchFamily="34" charset="-120"/>
+              </a:rPr>
+              <a:t>24</a:t>
+            </a:r>
+            <a:endParaRPr lang="en-US" sz="1000" dirty="0"/>
+          </a:p>
+        </p:txBody>
+      </p:sp>
+      <p:sp>
+        <p:nvSpPr>
           <p:cNvPr id="7" name="Text 4"/>
           <p:cNvSpPr txBox="1"/>
           <p:nvPr/>
         </p:nvSpPr>
         <p:spPr>
           <a:xfrm>
-            <a:off x="457200" y="1234440"/>
+            <a:off x="457200" y="1188720"/>
             <a:ext cx="548640" cy="411480"/>
           </a:xfrm>
           <a:prstGeom prst="rect">
@@ -12660,7 +15279,7 @@
         </p:nvSpPr>
         <p:spPr>
           <a:xfrm>
-            <a:off x="1005840" y="1234440"/>
+            <a:off x="1005840" y="1188720"/>
             <a:ext cx="2103120" cy="411480"/>
           </a:xfrm>
           <a:prstGeom prst="rect">
@@ -12699,7 +15318,7 @@
         </p:nvSpPr>
         <p:spPr>
           <a:xfrm>
-            <a:off x="457200" y="1783080"/>
+            <a:off x="457200" y="1664208"/>
             <a:ext cx="548640" cy="411480"/>
           </a:xfrm>
           <a:prstGeom prst="rect">
@@ -12738,7 +15357,7 @@
         </p:nvSpPr>
         <p:spPr>
           <a:xfrm>
-            <a:off x="1005840" y="1783080"/>
+            <a:off x="1005840" y="1664208"/>
             <a:ext cx="2103120" cy="411480"/>
           </a:xfrm>
           <a:prstGeom prst="rect">
@@ -12777,7 +15396,7 @@
         </p:nvSpPr>
         <p:spPr>
           <a:xfrm>
-            <a:off x="457200" y="2331720"/>
+            <a:off x="457200" y="2139696"/>
             <a:ext cx="548640" cy="411480"/>
           </a:xfrm>
           <a:prstGeom prst="rect">
@@ -12816,7 +15435,7 @@
         </p:nvSpPr>
         <p:spPr>
           <a:xfrm>
-            <a:off x="1005840" y="2331720"/>
+            <a:off x="1005840" y="2139696"/>
             <a:ext cx="2103120" cy="411480"/>
           </a:xfrm>
           <a:prstGeom prst="rect">
@@ -12855,7 +15474,7 @@
         </p:nvSpPr>
         <p:spPr>
           <a:xfrm>
-            <a:off x="457200" y="2880360"/>
+            <a:off x="457200" y="2615184"/>
             <a:ext cx="548640" cy="411480"/>
           </a:xfrm>
           <a:prstGeom prst="rect">
@@ -12894,7 +15513,7 @@
         </p:nvSpPr>
         <p:spPr>
           <a:xfrm>
-            <a:off x="1005840" y="2880360"/>
+            <a:off x="1005840" y="2615184"/>
             <a:ext cx="2103120" cy="411480"/>
           </a:xfrm>
           <a:prstGeom prst="rect">
@@ -12933,7 +15552,7 @@
         </p:nvSpPr>
         <p:spPr>
           <a:xfrm>
-            <a:off x="457200" y="3429000"/>
+            <a:off x="457200" y="3090672"/>
             <a:ext cx="548640" cy="411480"/>
           </a:xfrm>
           <a:prstGeom prst="rect">
@@ -12972,7 +15591,7 @@
         </p:nvSpPr>
         <p:spPr>
           <a:xfrm>
-            <a:off x="1005840" y="3429000"/>
+            <a:off x="1005840" y="3090672"/>
             <a:ext cx="2103120" cy="411480"/>
           </a:xfrm>
           <a:prstGeom prst="rect">
@@ -13011,7 +15630,85 @@
         </p:nvSpPr>
         <p:spPr>
           <a:xfrm>
-            <a:off x="1005840" y="4069080"/>
+            <a:off x="457200" y="3566160"/>
+            <a:ext cx="548640" cy="411480"/>
+          </a:xfrm>
+          <a:prstGeom prst="rect">
+            <a:avLst/>
+          </a:prstGeom>
+          <a:noFill/>
+          <a:ln/>
+        </p:spPr>
+        <p:txBody>
+          <a:bodyPr wrap="square" lIns="0" tIns="0" rIns="0" bIns="0" rtlCol="0" anchor="ctr"/>
+          <a:lstStyle/>
+          <a:p>
+            <a:pPr indent="0" marL="0">
+              <a:buNone/>
+            </a:pPr>
+            <a:r>
+              <a:rPr lang="en-US" sz="1400" b="1" dirty="0">
+                <a:solidFill>
+                  <a:srgbClr val="8C8C8C"/>
+                </a:solidFill>
+                <a:latin typeface="Arial" pitchFamily="34" charset="0"/>
+                <a:ea typeface="Arial" pitchFamily="34" charset="-122"/>
+                <a:cs typeface="Arial" pitchFamily="34" charset="-120"/>
+              </a:rPr>
+              <a:t>06</a:t>
+            </a:r>
+            <a:endParaRPr lang="en-US" sz="1400" dirty="0"/>
+          </a:p>
+        </p:txBody>
+      </p:sp>
+      <p:sp>
+        <p:nvSpPr>
+          <p:cNvPr id="18" name="Text 15"/>
+          <p:cNvSpPr txBox="1"/>
+          <p:nvPr/>
+        </p:nvSpPr>
+        <p:spPr>
+          <a:xfrm>
+            <a:off x="1005840" y="3566160"/>
+            <a:ext cx="2103120" cy="411480"/>
+          </a:xfrm>
+          <a:prstGeom prst="rect">
+            <a:avLst/>
+          </a:prstGeom>
+          <a:noFill/>
+          <a:ln/>
+        </p:spPr>
+        <p:txBody>
+          <a:bodyPr wrap="square" lIns="0" tIns="0" rIns="0" bIns="0" rtlCol="0" anchor="ctr"/>
+          <a:lstStyle/>
+          <a:p>
+            <a:pPr indent="0" marL="0">
+              <a:buNone/>
+            </a:pPr>
+            <a:r>
+              <a:rPr lang="en-US" sz="2000" b="1" dirty="0">
+                <a:solidFill>
+                  <a:srgbClr val="000000"/>
+                </a:solidFill>
+                <a:latin typeface="Arial" pitchFamily="34" charset="0"/>
+                <a:ea typeface="Arial" pitchFamily="34" charset="-122"/>
+                <a:cs typeface="Arial" pitchFamily="34" charset="-120"/>
+              </a:rPr>
+              <a:t>Implement</a:t>
+            </a:r>
+            <a:endParaRPr lang="en-US" sz="2000" dirty="0"/>
+          </a:p>
+        </p:txBody>
+      </p:sp>
+      <p:sp>
+        <p:nvSpPr>
+          <p:cNvPr id="19" name="Text 16"/>
+          <p:cNvSpPr txBox="1"/>
+          <p:nvPr/>
+        </p:nvSpPr>
+        <p:spPr>
+          <a:xfrm>
+            <a:off x="1005840" y="4114800"/>
             <a:ext cx="2743200" cy="320040"/>
           </a:xfrm>
           <a:prstGeom prst="rect">
@@ -13044,7 +15741,7 @@
       </p:sp>
       <p:sp>
         <p:nvSpPr>
-          <p:cNvPr id="18" name="Text 15"/>
+          <p:cNvPr id="20" name="Text 17"/>
           <p:cNvSpPr txBox="1"/>
           <p:nvPr/>
         </p:nvSpPr>
@@ -13075,7 +15772,7 @@
                 <a:ea typeface="Arial" pitchFamily="34" charset="-122"/>
                 <a:cs typeface="Arial" pitchFamily="34" charset="-120"/>
               </a:rPr>
-              <a:t>The build is done. The next step is Empathize again, this time face to face.</a:t>
+              <a:t>The build is done and ready to roll out. The next step is Empathize again, this time face to face.</a:t>
             </a:r>
             <a:endParaRPr lang="en-US" sz="1700" dirty="0"/>
           </a:p>
@@ -13083,7 +15780,7 @@
       </p:sp>
       <p:sp>
         <p:nvSpPr>
-          <p:cNvPr id="19" name="Text 16"/>
+          <p:cNvPr id="21" name="Text 18"/>
           <p:cNvSpPr txBox="1"/>
           <p:nvPr/>
         </p:nvSpPr>
@@ -13252,7 +15949,7 @@
                 <a:ea typeface="Arial" pitchFamily="34" charset="-122"/>
                 <a:cs typeface="Arial" pitchFamily="34" charset="-120"/>
               </a:rPr>
-              <a:t>Design thinking in five steps</a:t>
+              <a:t>Design thinking in six steps</a:t>
             </a:r>
             <a:endParaRPr lang="en-US" sz="3000" dirty="0"/>
           </a:p>
@@ -13383,8 +16080,8 @@
         </p:nvSpPr>
         <p:spPr>
           <a:xfrm>
-            <a:off x="182880" y="1280160"/>
-            <a:ext cx="1645920" cy="731520"/>
+            <a:off x="502920" y="1280160"/>
+            <a:ext cx="1280160" cy="731520"/>
           </a:xfrm>
           <a:prstGeom prst="rect">
             <a:avLst/>
@@ -13400,7 +16097,7 @@
               <a:buNone/>
             </a:pPr>
             <a:r>
-              <a:rPr lang="en-US" sz="4400" b="1" dirty="0">
+              <a:rPr lang="en-US" sz="4000" b="1" dirty="0">
                 <a:solidFill>
                   <a:srgbClr val="000000"/>
                 </a:solidFill>
@@ -13410,7 +16107,7 @@
               </a:rPr>
               <a:t>01</a:t>
             </a:r>
-            <a:endParaRPr lang="en-US" sz="4400" dirty="0"/>
+            <a:endParaRPr lang="en-US" sz="4000" dirty="0"/>
           </a:p>
         </p:txBody>
       </p:sp>
@@ -13422,8 +16119,8 @@
         </p:nvSpPr>
         <p:spPr>
           <a:xfrm>
-            <a:off x="182880" y="2377440"/>
-            <a:ext cx="1645920" cy="365760"/>
+            <a:off x="484632" y="2377440"/>
+            <a:ext cx="1316736" cy="365760"/>
           </a:xfrm>
           <a:prstGeom prst="rect">
             <a:avLst/>
@@ -13439,7 +16136,7 @@
               <a:buNone/>
             </a:pPr>
             <a:r>
-              <a:rPr lang="en-US" sz="1800" b="1" dirty="0">
+              <a:rPr lang="en-US" sz="1500" b="1" dirty="0">
                 <a:solidFill>
                   <a:srgbClr val="000000"/>
                 </a:solidFill>
@@ -13449,7 +16146,7 @@
               </a:rPr>
               <a:t>Empathize</a:t>
             </a:r>
-            <a:endParaRPr lang="en-US" sz="1800" dirty="0"/>
+            <a:endParaRPr lang="en-US" sz="1500" dirty="0"/>
           </a:p>
         </p:txBody>
       </p:sp>
@@ -13461,8 +16158,8 @@
         </p:nvSpPr>
         <p:spPr>
           <a:xfrm>
-            <a:off x="228600" y="2788920"/>
-            <a:ext cx="1554480" cy="822960"/>
+            <a:off x="521208" y="2788920"/>
+            <a:ext cx="1243584" cy="914400"/>
           </a:xfrm>
           <a:prstGeom prst="rect">
             <a:avLst/>
@@ -13500,8 +16197,8 @@
         </p:nvSpPr>
         <p:spPr>
           <a:xfrm>
-            <a:off x="1965960" y="1280160"/>
-            <a:ext cx="1645920" cy="731520"/>
+            <a:off x="1874520" y="1280160"/>
+            <a:ext cx="1280160" cy="731520"/>
           </a:xfrm>
           <a:prstGeom prst="rect">
             <a:avLst/>
@@ -13517,7 +16214,7 @@
               <a:buNone/>
             </a:pPr>
             <a:r>
-              <a:rPr lang="en-US" sz="4400" b="1" dirty="0">
+              <a:rPr lang="en-US" sz="4000" b="1" dirty="0">
                 <a:solidFill>
                   <a:srgbClr val="000000"/>
                 </a:solidFill>
@@ -13527,7 +16224,7 @@
               </a:rPr>
               <a:t>02</a:t>
             </a:r>
-            <a:endParaRPr lang="en-US" sz="4400" dirty="0"/>
+            <a:endParaRPr lang="en-US" sz="4000" dirty="0"/>
           </a:p>
         </p:txBody>
       </p:sp>
@@ -13539,8 +16236,8 @@
         </p:nvSpPr>
         <p:spPr>
           <a:xfrm>
-            <a:off x="1965960" y="2377440"/>
-            <a:ext cx="1645920" cy="365760"/>
+            <a:off x="1856232" y="2377440"/>
+            <a:ext cx="1316736" cy="365760"/>
           </a:xfrm>
           <a:prstGeom prst="rect">
             <a:avLst/>
@@ -13556,7 +16253,7 @@
               <a:buNone/>
             </a:pPr>
             <a:r>
-              <a:rPr lang="en-US" sz="1800" b="1" dirty="0">
+              <a:rPr lang="en-US" sz="1500" b="1" dirty="0">
                 <a:solidFill>
                   <a:srgbClr val="000000"/>
                 </a:solidFill>
@@ -13566,7 +16263,7 @@
               </a:rPr>
               <a:t>Define</a:t>
             </a:r>
-            <a:endParaRPr lang="en-US" sz="1800" dirty="0"/>
+            <a:endParaRPr lang="en-US" sz="1500" dirty="0"/>
           </a:p>
         </p:txBody>
       </p:sp>
@@ -13578,8 +16275,8 @@
         </p:nvSpPr>
         <p:spPr>
           <a:xfrm>
-            <a:off x="2011680" y="2788920"/>
-            <a:ext cx="1554480" cy="822960"/>
+            <a:off x="1892808" y="2788920"/>
+            <a:ext cx="1243584" cy="914400"/>
           </a:xfrm>
           <a:prstGeom prst="rect">
             <a:avLst/>
@@ -13617,8 +16314,8 @@
         </p:nvSpPr>
         <p:spPr>
           <a:xfrm>
-            <a:off x="3749040" y="1280160"/>
-            <a:ext cx="1645920" cy="731520"/>
+            <a:off x="3246120" y="1280160"/>
+            <a:ext cx="1280160" cy="731520"/>
           </a:xfrm>
           <a:prstGeom prst="rect">
             <a:avLst/>
@@ -13634,7 +16331,7 @@
               <a:buNone/>
             </a:pPr>
             <a:r>
-              <a:rPr lang="en-US" sz="4400" b="1" dirty="0">
+              <a:rPr lang="en-US" sz="4000" b="1" dirty="0">
                 <a:solidFill>
                   <a:srgbClr val="000000"/>
                 </a:solidFill>
@@ -13644,7 +16341,7 @@
               </a:rPr>
               <a:t>03</a:t>
             </a:r>
-            <a:endParaRPr lang="en-US" sz="4400" dirty="0"/>
+            <a:endParaRPr lang="en-US" sz="4000" dirty="0"/>
           </a:p>
         </p:txBody>
       </p:sp>
@@ -13656,8 +16353,8 @@
         </p:nvSpPr>
         <p:spPr>
           <a:xfrm>
-            <a:off x="3749040" y="2377440"/>
-            <a:ext cx="1645920" cy="365760"/>
+            <a:off x="3227832" y="2377440"/>
+            <a:ext cx="1316736" cy="365760"/>
           </a:xfrm>
           <a:prstGeom prst="rect">
             <a:avLst/>
@@ -13673,7 +16370,7 @@
               <a:buNone/>
             </a:pPr>
             <a:r>
-              <a:rPr lang="en-US" sz="1800" b="1" dirty="0">
+              <a:rPr lang="en-US" sz="1500" b="1" dirty="0">
                 <a:solidFill>
                   <a:srgbClr val="000000"/>
                 </a:solidFill>
@@ -13683,7 +16380,7 @@
               </a:rPr>
               <a:t>Ideate</a:t>
             </a:r>
-            <a:endParaRPr lang="en-US" sz="1800" dirty="0"/>
+            <a:endParaRPr lang="en-US" sz="1500" dirty="0"/>
           </a:p>
         </p:txBody>
       </p:sp>
@@ -13695,8 +16392,8 @@
         </p:nvSpPr>
         <p:spPr>
           <a:xfrm>
-            <a:off x="3794760" y="2788920"/>
-            <a:ext cx="1554480" cy="822960"/>
+            <a:off x="3264408" y="2788920"/>
+            <a:ext cx="1243584" cy="914400"/>
           </a:xfrm>
           <a:prstGeom prst="rect">
             <a:avLst/>
@@ -13734,8 +16431,8 @@
         </p:nvSpPr>
         <p:spPr>
           <a:xfrm>
-            <a:off x="5532120" y="1280160"/>
-            <a:ext cx="1645920" cy="731520"/>
+            <a:off x="4617720" y="1280160"/>
+            <a:ext cx="1280160" cy="731520"/>
           </a:xfrm>
           <a:prstGeom prst="rect">
             <a:avLst/>
@@ -13751,7 +16448,7 @@
               <a:buNone/>
             </a:pPr>
             <a:r>
-              <a:rPr lang="en-US" sz="4400" b="1" dirty="0">
+              <a:rPr lang="en-US" sz="4000" b="1" dirty="0">
                 <a:solidFill>
                   <a:srgbClr val="000000"/>
                 </a:solidFill>
@@ -13761,7 +16458,7 @@
               </a:rPr>
               <a:t>04</a:t>
             </a:r>
-            <a:endParaRPr lang="en-US" sz="4400" dirty="0"/>
+            <a:endParaRPr lang="en-US" sz="4000" dirty="0"/>
           </a:p>
         </p:txBody>
       </p:sp>
@@ -13773,8 +16470,8 @@
         </p:nvSpPr>
         <p:spPr>
           <a:xfrm>
-            <a:off x="5532120" y="2377440"/>
-            <a:ext cx="1645920" cy="365760"/>
+            <a:off x="4599432" y="2377440"/>
+            <a:ext cx="1316736" cy="365760"/>
           </a:xfrm>
           <a:prstGeom prst="rect">
             <a:avLst/>
@@ -13790,7 +16487,7 @@
               <a:buNone/>
             </a:pPr>
             <a:r>
-              <a:rPr lang="en-US" sz="1800" b="1" dirty="0">
+              <a:rPr lang="en-US" sz="1500" b="1" dirty="0">
                 <a:solidFill>
                   <a:srgbClr val="000000"/>
                 </a:solidFill>
@@ -13800,7 +16497,7 @@
               </a:rPr>
               <a:t>Prototype</a:t>
             </a:r>
-            <a:endParaRPr lang="en-US" sz="1800" dirty="0"/>
+            <a:endParaRPr lang="en-US" sz="1500" dirty="0"/>
           </a:p>
         </p:txBody>
       </p:sp>
@@ -13812,8 +16509,8 @@
         </p:nvSpPr>
         <p:spPr>
           <a:xfrm>
-            <a:off x="5577840" y="2788920"/>
-            <a:ext cx="1554480" cy="822960"/>
+            <a:off x="4636008" y="2788920"/>
+            <a:ext cx="1243584" cy="914400"/>
           </a:xfrm>
           <a:prstGeom prst="rect">
             <a:avLst/>
@@ -13851,8 +16548,8 @@
         </p:nvSpPr>
         <p:spPr>
           <a:xfrm>
-            <a:off x="7315200" y="1280160"/>
-            <a:ext cx="1645920" cy="731520"/>
+            <a:off x="5989320" y="1280160"/>
+            <a:ext cx="1280160" cy="731520"/>
           </a:xfrm>
           <a:prstGeom prst="rect">
             <a:avLst/>
@@ -13868,7 +16565,7 @@
               <a:buNone/>
             </a:pPr>
             <a:r>
-              <a:rPr lang="en-US" sz="4400" b="1" dirty="0">
+              <a:rPr lang="en-US" sz="4000" b="1" dirty="0">
                 <a:solidFill>
                   <a:srgbClr val="000000"/>
                 </a:solidFill>
@@ -13878,7 +16575,7 @@
               </a:rPr>
               <a:t>05</a:t>
             </a:r>
-            <a:endParaRPr lang="en-US" sz="4400" dirty="0"/>
+            <a:endParaRPr lang="en-US" sz="4000" dirty="0"/>
           </a:p>
         </p:txBody>
       </p:sp>
@@ -13890,8 +16587,8 @@
         </p:nvSpPr>
         <p:spPr>
           <a:xfrm>
-            <a:off x="7315200" y="2377440"/>
-            <a:ext cx="1645920" cy="365760"/>
+            <a:off x="5971032" y="2377440"/>
+            <a:ext cx="1316736" cy="365760"/>
           </a:xfrm>
           <a:prstGeom prst="rect">
             <a:avLst/>
@@ -13907,7 +16604,7 @@
               <a:buNone/>
             </a:pPr>
             <a:r>
-              <a:rPr lang="en-US" sz="1800" b="1" dirty="0">
+              <a:rPr lang="en-US" sz="1500" b="1" dirty="0">
                 <a:solidFill>
                   <a:srgbClr val="000000"/>
                 </a:solidFill>
@@ -13917,7 +16614,7 @@
               </a:rPr>
               <a:t>Test</a:t>
             </a:r>
-            <a:endParaRPr lang="en-US" sz="1800" dirty="0"/>
+            <a:endParaRPr lang="en-US" sz="1500" dirty="0"/>
           </a:p>
         </p:txBody>
       </p:sp>
@@ -13929,8 +16626,8 @@
         </p:nvSpPr>
         <p:spPr>
           <a:xfrm>
-            <a:off x="7360920" y="2788920"/>
-            <a:ext cx="1554480" cy="822960"/>
+            <a:off x="6007608" y="2788920"/>
+            <a:ext cx="1243584" cy="914400"/>
           </a:xfrm>
           <a:prstGeom prst="rect">
             <a:avLst/>
@@ -13962,7 +16659,124 @@
       </p:sp>
       <p:sp>
         <p:nvSpPr>
-          <p:cNvPr id="22" name="Shape 19"/>
+          <p:cNvPr id="22" name="Text 19"/>
+          <p:cNvSpPr txBox="1"/>
+          <p:nvPr/>
+        </p:nvSpPr>
+        <p:spPr>
+          <a:xfrm>
+            <a:off x="7360920" y="1280160"/>
+            <a:ext cx="1280160" cy="731520"/>
+          </a:xfrm>
+          <a:prstGeom prst="rect">
+            <a:avLst/>
+          </a:prstGeom>
+          <a:noFill/>
+          <a:ln/>
+        </p:spPr>
+        <p:txBody>
+          <a:bodyPr wrap="square" lIns="0" tIns="0" rIns="0" bIns="0" rtlCol="0" anchor="ctr"/>
+          <a:lstStyle/>
+          <a:p>
+            <a:pPr algn="ctr" indent="0" marL="0">
+              <a:buNone/>
+            </a:pPr>
+            <a:r>
+              <a:rPr lang="en-US" sz="4000" b="1" dirty="0">
+                <a:solidFill>
+                  <a:srgbClr val="000000"/>
+                </a:solidFill>
+                <a:latin typeface="Arial" pitchFamily="34" charset="0"/>
+                <a:ea typeface="Arial" pitchFamily="34" charset="-122"/>
+                <a:cs typeface="Arial" pitchFamily="34" charset="-120"/>
+              </a:rPr>
+              <a:t>06</a:t>
+            </a:r>
+            <a:endParaRPr lang="en-US" sz="4000" dirty="0"/>
+          </a:p>
+        </p:txBody>
+      </p:sp>
+      <p:sp>
+        <p:nvSpPr>
+          <p:cNvPr id="23" name="Text 20"/>
+          <p:cNvSpPr txBox="1"/>
+          <p:nvPr/>
+        </p:nvSpPr>
+        <p:spPr>
+          <a:xfrm>
+            <a:off x="7342632" y="2377440"/>
+            <a:ext cx="1316736" cy="365760"/>
+          </a:xfrm>
+          <a:prstGeom prst="rect">
+            <a:avLst/>
+          </a:prstGeom>
+          <a:noFill/>
+          <a:ln/>
+        </p:spPr>
+        <p:txBody>
+          <a:bodyPr wrap="square" lIns="0" tIns="0" rIns="0" bIns="0" rtlCol="0" anchor="ctr"/>
+          <a:lstStyle/>
+          <a:p>
+            <a:pPr algn="ctr" indent="0" marL="0">
+              <a:buNone/>
+            </a:pPr>
+            <a:r>
+              <a:rPr lang="en-US" sz="1500" b="1" dirty="0">
+                <a:solidFill>
+                  <a:srgbClr val="000000"/>
+                </a:solidFill>
+                <a:latin typeface="Arial" pitchFamily="34" charset="0"/>
+                <a:ea typeface="Arial" pitchFamily="34" charset="-122"/>
+                <a:cs typeface="Arial" pitchFamily="34" charset="-120"/>
+              </a:rPr>
+              <a:t>Implement</a:t>
+            </a:r>
+            <a:endParaRPr lang="en-US" sz="1500" dirty="0"/>
+          </a:p>
+        </p:txBody>
+      </p:sp>
+      <p:sp>
+        <p:nvSpPr>
+          <p:cNvPr id="24" name="Text 21"/>
+          <p:cNvSpPr txBox="1"/>
+          <p:nvPr/>
+        </p:nvSpPr>
+        <p:spPr>
+          <a:xfrm>
+            <a:off x="7379208" y="2788920"/>
+            <a:ext cx="1243584" cy="914400"/>
+          </a:xfrm>
+          <a:prstGeom prst="rect">
+            <a:avLst/>
+          </a:prstGeom>
+          <a:noFill/>
+          <a:ln/>
+        </p:spPr>
+        <p:txBody>
+          <a:bodyPr wrap="square" lIns="0" tIns="0" rIns="0" bIns="0" rtlCol="0" anchor="t"/>
+          <a:lstStyle/>
+          <a:p>
+            <a:pPr algn="ctr" indent="0" marL="0">
+              <a:buNone/>
+            </a:pPr>
+            <a:r>
+              <a:rPr lang="en-US" sz="1200" dirty="0">
+                <a:solidFill>
+                  <a:srgbClr val="595959"/>
+                </a:solidFill>
+                <a:latin typeface="Arial" pitchFamily="34" charset="0"/>
+                <a:ea typeface="Arial" pitchFamily="34" charset="-122"/>
+                <a:cs typeface="Arial" pitchFamily="34" charset="-120"/>
+              </a:rPr>
+              <a:t>How do people start using it?</a:t>
+            </a:r>
+            <a:endParaRPr lang="en-US" sz="1200" dirty="0"/>
+          </a:p>
+        </p:txBody>
+      </p:sp>
+      <p:sp>
+        <p:nvSpPr>
+          <p:cNvPr id="25" name="Shape 22"/>
           <p:cNvSpPr/>
           <p:nvPr/>
         </p:nvSpPr>
@@ -13987,7 +16801,7 @@
       </p:sp>
       <p:sp>
         <p:nvSpPr>
-          <p:cNvPr id="23" name="Text 20"/>
+          <p:cNvPr id="26" name="Text 23"/>
           <p:cNvSpPr txBox="1"/>
           <p:nvPr/>
         </p:nvSpPr>
@@ -14018,7 +16832,7 @@
                 <a:ea typeface="Arial" pitchFamily="34" charset="-122"/>
                 <a:cs typeface="Arial" pitchFamily="34" charset="-120"/>
               </a:rPr>
-              <a:t>It is a loop, not a line: what we learn while testing sends us back to the people.</a:t>
+              <a:t>It is a loop, not a line: what we learn from testing and rollout sends us back to the people.</a:t>
             </a:r>
             <a:endParaRPr lang="en-US" sz="1500" dirty="0"/>
           </a:p>
@@ -14181,8 +16995,8 @@
         </p:nvSpPr>
         <p:spPr>
           <a:xfrm>
-            <a:off x="548640" y="3429000"/>
-            <a:ext cx="457200" cy="256032"/>
+            <a:off x="548640" y="3108960"/>
+            <a:ext cx="457200" cy="246888"/>
           </a:xfrm>
           <a:prstGeom prst="rect">
             <a:avLst/>
@@ -14220,8 +17034,8 @@
         </p:nvSpPr>
         <p:spPr>
           <a:xfrm>
-            <a:off x="1005840" y="3429000"/>
-            <a:ext cx="2743200" cy="256032"/>
+            <a:off x="1005840" y="3108960"/>
+            <a:ext cx="2743200" cy="246888"/>
           </a:xfrm>
           <a:prstGeom prst="rect">
             <a:avLst/>
@@ -14259,8 +17073,8 @@
         </p:nvSpPr>
         <p:spPr>
           <a:xfrm>
-            <a:off x="548640" y="3685032"/>
-            <a:ext cx="457200" cy="256032"/>
+            <a:off x="548640" y="3355848"/>
+            <a:ext cx="457200" cy="246888"/>
           </a:xfrm>
           <a:prstGeom prst="rect">
             <a:avLst/>
@@ -14298,8 +17112,8 @@
         </p:nvSpPr>
         <p:spPr>
           <a:xfrm>
-            <a:off x="1005840" y="3685032"/>
-            <a:ext cx="2743200" cy="256032"/>
+            <a:off x="1005840" y="3355848"/>
+            <a:ext cx="2743200" cy="246888"/>
           </a:xfrm>
           <a:prstGeom prst="rect">
             <a:avLst/>
@@ -14337,8 +17151,8 @@
         </p:nvSpPr>
         <p:spPr>
           <a:xfrm>
-            <a:off x="548640" y="3941064"/>
-            <a:ext cx="457200" cy="256032"/>
+            <a:off x="548640" y="3602736"/>
+            <a:ext cx="457200" cy="246888"/>
           </a:xfrm>
           <a:prstGeom prst="rect">
             <a:avLst/>
@@ -14376,8 +17190,8 @@
         </p:nvSpPr>
         <p:spPr>
           <a:xfrm>
-            <a:off x="1005840" y="3941064"/>
-            <a:ext cx="2743200" cy="256032"/>
+            <a:off x="1005840" y="3602736"/>
+            <a:ext cx="2743200" cy="246888"/>
           </a:xfrm>
           <a:prstGeom prst="rect">
             <a:avLst/>
@@ -14415,8 +17229,8 @@
         </p:nvSpPr>
         <p:spPr>
           <a:xfrm>
-            <a:off x="548640" y="4197096"/>
-            <a:ext cx="457200" cy="256032"/>
+            <a:off x="548640" y="3849624"/>
+            <a:ext cx="457200" cy="246888"/>
           </a:xfrm>
           <a:prstGeom prst="rect">
             <a:avLst/>
@@ -14454,8 +17268,8 @@
         </p:nvSpPr>
         <p:spPr>
           <a:xfrm>
-            <a:off x="1005840" y="4197096"/>
-            <a:ext cx="2743200" cy="256032"/>
+            <a:off x="1005840" y="3849624"/>
+            <a:ext cx="2743200" cy="246888"/>
           </a:xfrm>
           <a:prstGeom prst="rect">
             <a:avLst/>
@@ -14493,8 +17307,8 @@
         </p:nvSpPr>
         <p:spPr>
           <a:xfrm>
-            <a:off x="548640" y="4453128"/>
-            <a:ext cx="457200" cy="256032"/>
+            <a:off x="548640" y="4096512"/>
+            <a:ext cx="457200" cy="246888"/>
           </a:xfrm>
           <a:prstGeom prst="rect">
             <a:avLst/>
@@ -14532,8 +17346,8 @@
         </p:nvSpPr>
         <p:spPr>
           <a:xfrm>
-            <a:off x="1005840" y="4453128"/>
-            <a:ext cx="2743200" cy="256032"/>
+            <a:off x="1005840" y="4096512"/>
+            <a:ext cx="2743200" cy="246888"/>
           </a:xfrm>
           <a:prstGeom prst="rect">
             <a:avLst/>
@@ -14565,7 +17379,85 @@
       </p:sp>
       <p:sp>
         <p:nvSpPr>
-          <p:cNvPr id="16" name="Shape 13"/>
+          <p:cNvPr id="16" name="Text 13"/>
+          <p:cNvSpPr txBox="1"/>
+          <p:nvPr/>
+        </p:nvSpPr>
+        <p:spPr>
+          <a:xfrm>
+            <a:off x="548640" y="4343400"/>
+            <a:ext cx="457200" cy="246888"/>
+          </a:xfrm>
+          <a:prstGeom prst="rect">
+            <a:avLst/>
+          </a:prstGeom>
+          <a:noFill/>
+          <a:ln/>
+        </p:spPr>
+        <p:txBody>
+          <a:bodyPr wrap="square" lIns="0" tIns="0" rIns="0" bIns="0" rtlCol="0" anchor="ctr"/>
+          <a:lstStyle/>
+          <a:p>
+            <a:pPr indent="0" marL="0">
+              <a:buNone/>
+            </a:pPr>
+            <a:r>
+              <a:rPr lang="en-US" sz="1200" b="1" dirty="0">
+                <a:solidFill>
+                  <a:srgbClr val="595959"/>
+                </a:solidFill>
+                <a:latin typeface="Arial" pitchFamily="34" charset="0"/>
+                <a:ea typeface="Arial" pitchFamily="34" charset="-122"/>
+                <a:cs typeface="Arial" pitchFamily="34" charset="-120"/>
+              </a:rPr>
+              <a:t>06</a:t>
+            </a:r>
+            <a:endParaRPr lang="en-US" sz="1200" dirty="0"/>
+          </a:p>
+        </p:txBody>
+      </p:sp>
+      <p:sp>
+        <p:nvSpPr>
+          <p:cNvPr id="17" name="Text 14"/>
+          <p:cNvSpPr txBox="1"/>
+          <p:nvPr/>
+        </p:nvSpPr>
+        <p:spPr>
+          <a:xfrm>
+            <a:off x="1005840" y="4343400"/>
+            <a:ext cx="2743200" cy="246888"/>
+          </a:xfrm>
+          <a:prstGeom prst="rect">
+            <a:avLst/>
+          </a:prstGeom>
+          <a:noFill/>
+          <a:ln/>
+        </p:spPr>
+        <p:txBody>
+          <a:bodyPr wrap="square" lIns="0" tIns="0" rIns="0" bIns="0" rtlCol="0" anchor="ctr"/>
+          <a:lstStyle/>
+          <a:p>
+            <a:pPr indent="0" marL="0">
+              <a:buNone/>
+            </a:pPr>
+            <a:r>
+              <a:rPr lang="en-US" sz="1200" dirty="0">
+                <a:solidFill>
+                  <a:srgbClr val="595959"/>
+                </a:solidFill>
+                <a:latin typeface="Arial" pitchFamily="34" charset="0"/>
+                <a:ea typeface="Arial" pitchFamily="34" charset="-122"/>
+                <a:cs typeface="Arial" pitchFamily="34" charset="-120"/>
+              </a:rPr>
+              <a:t>Implement</a:t>
+            </a:r>
+            <a:endParaRPr lang="en-US" sz="1200" dirty="0"/>
+          </a:p>
+        </p:txBody>
+      </p:sp>
+      <p:sp>
+        <p:nvSpPr>
+          <p:cNvPr id="18" name="Shape 15"/>
           <p:cNvSpPr/>
           <p:nvPr/>
         </p:nvSpPr>
@@ -14590,7 +17482,7 @@
       </p:sp>
       <p:sp>
         <p:nvSpPr>
-          <p:cNvPr id="17" name="Text 14"/>
+          <p:cNvPr id="19" name="Text 16"/>
           <p:cNvSpPr txBox="1"/>
           <p:nvPr/>
         </p:nvSpPr>
@@ -14629,7 +17521,7 @@
       </p:sp>
       <p:sp>
         <p:nvSpPr>
-          <p:cNvPr id="18" name="Text 15"/>
+          <p:cNvPr id="20" name="Text 17"/>
           <p:cNvSpPr txBox="1"/>
           <p:nvPr/>
         </p:nvSpPr>
@@ -14668,7 +17560,7 @@
       </p:sp>
       <p:sp>
         <p:nvSpPr>
-          <p:cNvPr id="19" name="Text 16"/>
+          <p:cNvPr id="21" name="Text 18"/>
           <p:cNvSpPr txBox="1"/>
           <p:nvPr/>
         </p:nvSpPr>
@@ -14707,7 +17599,7 @@
       </p:sp>
       <p:sp>
         <p:nvSpPr>
-          <p:cNvPr id="20" name="Text 17"/>
+          <p:cNvPr id="22" name="Text 19"/>
           <p:cNvSpPr txBox="1"/>
           <p:nvPr/>
         </p:nvSpPr>
@@ -14746,7 +17638,7 @@
       </p:sp>
       <p:sp>
         <p:nvSpPr>
-          <p:cNvPr id="21" name="Text 18"/>
+          <p:cNvPr id="23" name="Text 20"/>
           <p:cNvSpPr txBox="1"/>
           <p:nvPr/>
         </p:nvSpPr>
@@ -14785,7 +17677,7 @@
       </p:sp>
       <p:sp>
         <p:nvSpPr>
-          <p:cNvPr id="22" name="Text 19"/>
+          <p:cNvPr id="24" name="Text 21"/>
           <p:cNvSpPr txBox="1"/>
           <p:nvPr/>
         </p:nvSpPr>
@@ -16157,8 +19049,8 @@
         </p:nvSpPr>
         <p:spPr>
           <a:xfrm>
-            <a:off x="548640" y="3429000"/>
-            <a:ext cx="457200" cy="256032"/>
+            <a:off x="548640" y="3108960"/>
+            <a:ext cx="457200" cy="246888"/>
           </a:xfrm>
           <a:prstGeom prst="rect">
             <a:avLst/>
@@ -16196,8 +19088,8 @@
         </p:nvSpPr>
         <p:spPr>
           <a:xfrm>
-            <a:off x="1005840" y="3429000"/>
-            <a:ext cx="2743200" cy="256032"/>
+            <a:off x="1005840" y="3108960"/>
+            <a:ext cx="2743200" cy="246888"/>
           </a:xfrm>
           <a:prstGeom prst="rect">
             <a:avLst/>
@@ -16235,8 +19127,8 @@
         </p:nvSpPr>
         <p:spPr>
           <a:xfrm>
-            <a:off x="548640" y="3685032"/>
-            <a:ext cx="457200" cy="256032"/>
+            <a:off x="548640" y="3355848"/>
+            <a:ext cx="457200" cy="246888"/>
           </a:xfrm>
           <a:prstGeom prst="rect">
             <a:avLst/>
@@ -16274,8 +19166,8 @@
         </p:nvSpPr>
         <p:spPr>
           <a:xfrm>
-            <a:off x="1005840" y="3685032"/>
-            <a:ext cx="2743200" cy="256032"/>
+            <a:off x="1005840" y="3355848"/>
+            <a:ext cx="2743200" cy="246888"/>
           </a:xfrm>
           <a:prstGeom prst="rect">
             <a:avLst/>
@@ -16313,8 +19205,8 @@
         </p:nvSpPr>
         <p:spPr>
           <a:xfrm>
-            <a:off x="548640" y="3941064"/>
-            <a:ext cx="457200" cy="256032"/>
+            <a:off x="548640" y="3602736"/>
+            <a:ext cx="457200" cy="246888"/>
           </a:xfrm>
           <a:prstGeom prst="rect">
             <a:avLst/>
@@ -16352,8 +19244,8 @@
         </p:nvSpPr>
         <p:spPr>
           <a:xfrm>
-            <a:off x="1005840" y="3941064"/>
-            <a:ext cx="2743200" cy="256032"/>
+            <a:off x="1005840" y="3602736"/>
+            <a:ext cx="2743200" cy="246888"/>
           </a:xfrm>
           <a:prstGeom prst="rect">
             <a:avLst/>
@@ -16391,8 +19283,8 @@
         </p:nvSpPr>
         <p:spPr>
           <a:xfrm>
-            <a:off x="548640" y="4197096"/>
-            <a:ext cx="457200" cy="256032"/>
+            <a:off x="548640" y="3849624"/>
+            <a:ext cx="457200" cy="246888"/>
           </a:xfrm>
           <a:prstGeom prst="rect">
             <a:avLst/>
@@ -16430,8 +19322,8 @@
         </p:nvSpPr>
         <p:spPr>
           <a:xfrm>
-            <a:off x="1005840" y="4197096"/>
-            <a:ext cx="2743200" cy="256032"/>
+            <a:off x="1005840" y="3849624"/>
+            <a:ext cx="2743200" cy="246888"/>
           </a:xfrm>
           <a:prstGeom prst="rect">
             <a:avLst/>
@@ -16469,8 +19361,8 @@
         </p:nvSpPr>
         <p:spPr>
           <a:xfrm>
-            <a:off x="548640" y="4453128"/>
-            <a:ext cx="457200" cy="256032"/>
+            <a:off x="548640" y="4096512"/>
+            <a:ext cx="457200" cy="246888"/>
           </a:xfrm>
           <a:prstGeom prst="rect">
             <a:avLst/>
@@ -16508,8 +19400,8 @@
         </p:nvSpPr>
         <p:spPr>
           <a:xfrm>
-            <a:off x="1005840" y="4453128"/>
-            <a:ext cx="2743200" cy="256032"/>
+            <a:off x="1005840" y="4096512"/>
+            <a:ext cx="2743200" cy="246888"/>
           </a:xfrm>
           <a:prstGeom prst="rect">
             <a:avLst/>
@@ -16541,7 +19433,85 @@
       </p:sp>
       <p:sp>
         <p:nvSpPr>
-          <p:cNvPr id="16" name="Shape 13"/>
+          <p:cNvPr id="16" name="Text 13"/>
+          <p:cNvSpPr txBox="1"/>
+          <p:nvPr/>
+        </p:nvSpPr>
+        <p:spPr>
+          <a:xfrm>
+            <a:off x="548640" y="4343400"/>
+            <a:ext cx="457200" cy="246888"/>
+          </a:xfrm>
+          <a:prstGeom prst="rect">
+            <a:avLst/>
+          </a:prstGeom>
+          <a:noFill/>
+          <a:ln/>
+        </p:spPr>
+        <p:txBody>
+          <a:bodyPr wrap="square" lIns="0" tIns="0" rIns="0" bIns="0" rtlCol="0" anchor="ctr"/>
+          <a:lstStyle/>
+          <a:p>
+            <a:pPr indent="0" marL="0">
+              <a:buNone/>
+            </a:pPr>
+            <a:r>
+              <a:rPr lang="en-US" sz="1200" b="1" dirty="0">
+                <a:solidFill>
+                  <a:srgbClr val="595959"/>
+                </a:solidFill>
+                <a:latin typeface="Arial" pitchFamily="34" charset="0"/>
+                <a:ea typeface="Arial" pitchFamily="34" charset="-122"/>
+                <a:cs typeface="Arial" pitchFamily="34" charset="-120"/>
+              </a:rPr>
+              <a:t>06</a:t>
+            </a:r>
+            <a:endParaRPr lang="en-US" sz="1200" dirty="0"/>
+          </a:p>
+        </p:txBody>
+      </p:sp>
+      <p:sp>
+        <p:nvSpPr>
+          <p:cNvPr id="17" name="Text 14"/>
+          <p:cNvSpPr txBox="1"/>
+          <p:nvPr/>
+        </p:nvSpPr>
+        <p:spPr>
+          <a:xfrm>
+            <a:off x="1005840" y="4343400"/>
+            <a:ext cx="2743200" cy="246888"/>
+          </a:xfrm>
+          <a:prstGeom prst="rect">
+            <a:avLst/>
+          </a:prstGeom>
+          <a:noFill/>
+          <a:ln/>
+        </p:spPr>
+        <p:txBody>
+          <a:bodyPr wrap="square" lIns="0" tIns="0" rIns="0" bIns="0" rtlCol="0" anchor="ctr"/>
+          <a:lstStyle/>
+          <a:p>
+            <a:pPr indent="0" marL="0">
+              <a:buNone/>
+            </a:pPr>
+            <a:r>
+              <a:rPr lang="en-US" sz="1200" dirty="0">
+                <a:solidFill>
+                  <a:srgbClr val="595959"/>
+                </a:solidFill>
+                <a:latin typeface="Arial" pitchFamily="34" charset="0"/>
+                <a:ea typeface="Arial" pitchFamily="34" charset="-122"/>
+                <a:cs typeface="Arial" pitchFamily="34" charset="-120"/>
+              </a:rPr>
+              <a:t>Implement</a:t>
+            </a:r>
+            <a:endParaRPr lang="en-US" sz="1200" dirty="0"/>
+          </a:p>
+        </p:txBody>
+      </p:sp>
+      <p:sp>
+        <p:nvSpPr>
+          <p:cNvPr id="18" name="Shape 15"/>
           <p:cNvSpPr/>
           <p:nvPr/>
         </p:nvSpPr>
@@ -16566,7 +19536,7 @@
       </p:sp>
       <p:sp>
         <p:nvSpPr>
-          <p:cNvPr id="17" name="Text 14"/>
+          <p:cNvPr id="19" name="Text 16"/>
           <p:cNvSpPr txBox="1"/>
           <p:nvPr/>
         </p:nvSpPr>
@@ -16605,7 +19575,7 @@
       </p:sp>
       <p:sp>
         <p:nvSpPr>
-          <p:cNvPr id="18" name="Text 15"/>
+          <p:cNvPr id="20" name="Text 17"/>
           <p:cNvSpPr txBox="1"/>
           <p:nvPr/>
         </p:nvSpPr>
@@ -16644,7 +19614,7 @@
       </p:sp>
       <p:sp>
         <p:nvSpPr>
-          <p:cNvPr id="19" name="Text 16"/>
+          <p:cNvPr id="21" name="Text 18"/>
           <p:cNvSpPr txBox="1"/>
           <p:nvPr/>
         </p:nvSpPr>
@@ -16683,7 +19653,7 @@
       </p:sp>
       <p:sp>
         <p:nvSpPr>
-          <p:cNvPr id="20" name="Text 17"/>
+          <p:cNvPr id="22" name="Text 19"/>
           <p:cNvSpPr txBox="1"/>
           <p:nvPr/>
         </p:nvSpPr>
@@ -16722,7 +19692,7 @@
       </p:sp>
       <p:sp>
         <p:nvSpPr>
-          <p:cNvPr id="21" name="Text 18"/>
+          <p:cNvPr id="23" name="Text 20"/>
           <p:cNvSpPr txBox="1"/>
           <p:nvPr/>
         </p:nvSpPr>
@@ -16761,7 +19731,7 @@
       </p:sp>
       <p:sp>
         <p:nvSpPr>
-          <p:cNvPr id="22" name="Text 19"/>
+          <p:cNvPr id="24" name="Text 21"/>
           <p:cNvSpPr txBox="1"/>
           <p:nvPr/>
         </p:nvSpPr>

</xml_diff>